<commit_message>
output: FAIR Vietnamese .pptx re-exported with the new result-3 slide
</commit_message>
<xml_diff>
--- a/output/pdfs/FAIR2026_slides_vi.pptx
+++ b/output/pdfs/FAIR2026_slides_vi.pptx
@@ -1482,13 +1482,13 @@
           <a:lstStyle/>
           <a:p>
             <a:r>
-              <a:t>Nói: Ở kết quả 1, hai con số 0,9971 và 0,9970 chỉ là một lần chạy. Để chắc chắn, chúng tôi lặp lại với sáu cách chia dữ liệu khác nhau, mỗi lần cả hai cấu hình dùng cùng một cách chia. F1 trung bình chênh nhau khoảng 0,0001. Chúng tôi không dừng ở câu hỏi hai bên có khác nhau không, mà kiểm định trực tiếp rằng hai bên tương đương, bằng kiểm định TOST. Kết quả là chênh lệch thực sự nhỏ hơn 0,00023 F1. Vì hai bên tương đương, chúng tôi chọn SHAP Top-30: ít đặc trưng hơn và giải thích được.</a:t>
+              <a:t>Nói: Ở kết quả 1, hai con số 0,9971 và 0,9970 chỉ là một lần chạy. Để chắc chắn, chúng tôi lặp lại với sáu cách chia dữ liệu khác nhau, mỗi lần cả hai cấu hình dùng cùng một cách chia. F1 trung bình chênh nhau khoảng 0,0001. Chúng tôi dùng hai kiểm định. Kiểm định hoán vị ghép cặp hỏi hai bên có khác nhau không; nó so từng cặp và tính chính xác được với chỉ sáu cặp. Kết quả p bằng 0,031, tức là có khác biệt, nhưng khác biệt chỉ khoảng 0,0001 F1. Kiểm định này không trả lời được câu hai bên có giống nhau không, nên chúng tôi dùng thêm kiểm định tương đương TOST, với biên cộng trừ 0,001 F1 chọn trước khi chạy. p bằng 3,9 nhân 10 mũ trừ 6, nên hai bên tương đương, chênh lệch thực sự nhỏ hơn 0,00023 F1. Vì vậy chúng tôi chọn SHAP Top-30: ít đặc trưng hơn và giải thích được.</a:t>
             </a:r>
           </a:p>
           <a:p/>
           <a:p>
             <a:r>
-              <a:t>Nếu bị hỏi: TOST ở mức ý nghĩa 5%. Kiểm định hoán vị ghép cặp liệt kê đủ 26 tổ hợp dấu cho p = 0,031, đúng sàn phân giải 2/26, Cohen’s d ≈ 1,94. Một p như vậy không chứng minh được tương đương, nên dùng TOST với biên ±0,001 F1 khai báo trước, trên sai số hiệu chỉnh Nadeau–Bengio: p = 3,9 × 10−6, biên nhỏ nhất chứng minh được TOST là ±2,3 × 10−4. Xem slide dự phòng.</a:t>
+              <a:t>Nếu bị hỏi: p = 0,031 là đúng sàn phân giải 2/26 của kiểm định hoán vị hai phía liệt kê đủ 26 tổ hợp dấu, nên cần N ≥ 6. Cohen’s d ≈ 1,94 lớn vì phương sai giữa các lần chạy rất nhỏ, không phải vì chênh lệch lớn. TOST dùng sai số hiệu chỉnh Nadeau–Bengio vì các lần lấy mẫu chồng nhau; biên nhỏ nhất chứng minh được ở α = 0,05 là ±2,3×10−4. Xem slide dự phòng.</a:t>
             </a:r>
           </a:p>
         </p:txBody>

</xml_diff>

<commit_message>
output: FAIR Vietnamese .pptx re-exported with the question-answer statistics slide
</commit_message>
<xml_diff>
--- a/output/pdfs/FAIR2026_slides_vi.pptx
+++ b/output/pdfs/FAIR2026_slides_vi.pptx
@@ -1482,13 +1482,13 @@
           <a:lstStyle/>
           <a:p>
             <a:r>
-              <a:t>Nói: Ở kết quả 1, hai con số 0,9971 và 0,9970 chỉ là một lần chạy. Để chắc chắn, chúng tôi lặp lại với sáu cách chia dữ liệu khác nhau, mỗi lần cả hai cấu hình dùng cùng một cách chia. F1 trung bình chênh nhau khoảng 0,0001. Chúng tôi dùng ba phép thống kê, bảng dưới. Một, khoảng tin cậy hiệu chỉnh Nadeau–Bengio, vì các lần chạy dùng chung dữ liệu nên khoảng tin cậy thông thường hẹp quá; kết quả cộng trừ 0,00012 và 0,00015. Hai, kiểm định hoán vị ghép cặp hỏi hai bên có khác nhau không: p bằng 0,031, có khác nhưng rất nhỏ. Ba, phép này không chứng minh được hai bên giống nhau, nên chúng tôi dùng kiểm định tương đương TOST với biên cộng trừ 0,001 F1 chọn trước: p bằng 3,9 nhân 10 mũ trừ 6, tức là tương đương. Trên hình, đoạn xanh dương là chênh lệch thật, từ 0,00005 đến 0,00023: lệch khỏi 0 một chút nhưng nằm gọn trong vùng xanh lá. Vì vậy chúng tôi chọn SHAP Top-30: ít đặc trưng hơn và giải thích được.</a:t>
+              <a:t>Nói: Kết quả 1 chỉ là một lần chạy, nên chúng tôi chạy lại 6 lần. F1 hai bên chênh khoảng 0,0001. Chúng tôi trả lời ba câu hỏi. Một, số đo có chắc không? Chắc, sai số chỉ khoảng cộng trừ 0,0001. Hai, hai bên có khác nhau không? Có, nhưng rất nhỏ. Ba, có coi như nhau được không? Được. Nhìn hình: vùng xanh lá là mức chênh cộng trừ 0,001 mà chúng tôi chấp nhận, đặt trước khi chạy. Đoạn xanh dương là chênh lệch thật, nằm gọn trong đó. Vì vậy chọn SHAP Top-30: ít đặc trưng hơn mà tốt ngang, lại giải thích được.</a:t>
             </a:r>
           </a:p>
           <a:p/>
           <a:p>
             <a:r>
-              <a:t>Nếu bị hỏi: p = 0,031 là đúng sàn phân giải 2/26 của kiểm định hoán vị hai phía liệt kê đủ 26 tổ hợp dấu, nên cần N ≥ 6. Cohen’s d ≈ 1,94 lớn vì phương sai giữa các lần chạy rất nhỏ, không phải vì chênh lệch lớn. TOST dùng sai số hiệu chỉnh Nadeau–Bengio vì các lần lấy mẫu chồng nhau; biên nhỏ nhất chứng minh được ở α = 0,05 là ±2,3×10−4. Xem slide dự phòng.</a:t>
+              <a:t>Nếu bị hỏi: Phép 1: các lần chạy dùng chung dữ liệu nên khoảng tin cậy thông thường hẹp quá, Nadeau–Bengio hiệu chỉnh việc đó. Phép 2: kiểm định hoán vị hai phía liệt kê đủ 26 tổ hợp dấu, nên p nhỏ nhất là 2/26 = 0,031, cần N ≥ 6. Cohen’s d ≈ 1,94 lớn vì phương sai giữa các lần chạy rất nhỏ, không phải vì chênh lệch lớn. Phép 3: p của phép 2 không chứng minh được hai bên giống nhau, nên dùng TOST với biên ±0,001 F1 trên sai số Nadeau–Bengio; biên nhỏ nhất chứng minh được ở α = 0,05 là ±2,3 × 10−4. Xem slide dự phòng.</a:t>
             </a:r>
           </a:p>
         </p:txBody>

</xml_diff>

<commit_message>
output: FAIR Vietnamese .pptx re-exported with question-answer result slides
</commit_message>
<xml_diff>
--- a/output/pdfs/FAIR2026_slides_vi.pptx
+++ b/output/pdfs/FAIR2026_slides_vi.pptx
@@ -588,7 +588,7 @@
           <a:lstStyle/>
           <a:p>
             <a:r>
-              <a:t>Nói: Đến đây mới chỉ hỏi có tấn công hay không. Khi hỏi là loại tấn công nào thì kết quả khác hẳn. Điểm tổng vẫn là 0,998, nhưng nếu tính trung bình đều cho từng lớp thì chỉ còn 0,806. Lý do là các lớp hiếm. Bot chỉ phát hiện được 46%. XSS gần 3%. SQL Injection có 6 mẫu, không phát hiện được mẫu nào. Có hai kiểu sai cần phân biệt. Kiểu ít nghiêm trọng là nhầm loại nhưng vẫn phát hiện: 76% XSS vẫn bị báo là tấn công. Kiểu nghiêm trọng là bỏ sót: cả 6 SQL Injection và 54% Bot bị phân loại là bình thường.</a:t>
+              <a:t>Nói: Đến đây mới chỉ hỏi có tấn công hay không. Giờ hỏi là loại tấn công nào. Một, điểm tổng có phản ánh đúng không? Không: điểm chung là 0,998, nhưng tính đều cho từng lớp thì chỉ còn 0,806. Hai, lớp nào bị bỏ sót? Các lớp hiếm: cả 6 mẫu SQL Injection và 54% Bot bị xếp là bình thường. Ba, XSS chỉ phát hiện đúng 2,7%, có phải bỏ sót không? Phần lớn không: 76% XSS vẫn bị báo là tấn công, chỉ nhầm sang loại khác. Bỏ sót mới là lỗi nghiêm trọng.</a:t>
             </a:r>
           </a:p>
           <a:p/>
@@ -664,7 +664,7 @@
           <a:lstStyle/>
           <a:p>
             <a:r>
-              <a:t>Nói: Đây là kết quả quan trọng nhất. Huấn luyện và kiểm tra trên cùng một bộ thì F1 là 0,995. Nhưng huấn luyện trên bộ 2017 rồi kiểm tra trên bộ 2018 thì F1 chỉ còn từ 0,03 đến 0,30. Chiều ngược lại còn 0,05. Mô hình bỏ sót gần hết tấn công của mạng mới. Hình bên phải cho thấy thêm một điều. Chúng tôi chạy 18 lần, cùng mã, cùng dữ liệu, và F1 rơi vào hai cụm tách hẳn nhau: 11 lần thấp, 7 lần cao, không lần nào ở giữa. Vì vậy báo một lần chạy là không đủ tin cậy. Chúng tôi báo cả 18 lần, và so sánh thêm bằng AUC-PR, là điểm xếp hạng không phụ thuộc ngưỡng, nên ổn định hơn F1.</a:t>
+              <a:t>Nói: Đây là kết quả quan trọng nhất. Một, sang mạng khác mô hình còn tốt không? Không: cùng bộ thì F1 là 0,995, sang bộ 2018 chỉ còn 0,03 đến 0,30. Chiều ngược lại, 0,925 còn 0,05. Hai, mô hình sai kiểu gì? Bỏ sót: chỉ phát hiện được 7% và 3% số tấn công. Ba, một lần chạy có đủ tin không? Không. Hình bên phải: 18 lần chạy cùng mã, cùng dữ liệu, F1 rơi vào hai cụm, 11 lần thấp, 7 lần cao, không lần nào ở giữa. Nên chúng tôi báo cả 18 lần và so sánh thêm bằng AUC-PR, là điểm không phụ thuộc ngưỡng nên ổn định hơn F1.</a:t>
             </a:r>
           </a:p>
           <a:p/>
@@ -740,7 +740,7 @@
           <a:lstStyle/>
           <a:p>
             <a:r>
-              <a:t>Nói: Vậy làm gì để mô hình hoạt động được trên mạng mới? Chúng tôi thử hai hướng. Hướng thứ nhất không cần nhãn: chỉ chỉnh phân phối dữ liệu của mạng mới cho giống dữ liệu cũ, gọi là căn chỉnh, ở đây dùng CORAL. Kết quả là F1 về 0 ở cả hai chiều. Hướng thứ hai: gán nhãn 1% dữ liệu của mạng mới, khoảng 19 nghìn luồng, rồi huấn luyện lại. F1 lên 0,92 và 0,99. Một điểm đáng chú ý: gộp thêm toàn bộ dữ liệu cũ vào thì kết quả lại giảm. Tức là muốn chuyển mô hình sang mạng mới, cách ít tốn kém nhất ở đây là gán nhãn một ít lưu lượng của chính mạng đó.</a:t>
+              <a:t>Nói: Vậy làm sao cho mô hình chạy được trên mạng mới? Một, chỉ chỉnh phân phối dữ liệu cho giống dữ liệu cũ, không cần nhãn, có được không? Không: F1 về 0 ở cả hai chiều. Hai, nếu gán nhãn thì cần bao nhiêu? Rất ít: 1%, khoảng 19 nghìn luồng, huấn luyện lại thì F1 lên 0,92 và 0,99. Ba, gộp thêm toàn bộ dữ liệu cũ có tốt hơn không? Không, lại kém hơn: 0,80 và 0,96. Vậy cách rẻ nhất là gán nhãn một ít lưu lượng của chính mạng mới.</a:t>
             </a:r>
           </a:p>
           <a:p/>
@@ -1330,7 +1330,7 @@
           <a:lstStyle/>
           <a:p>
             <a:r>
-              <a:t>Nói: Kết quả đầu tiên. Bảng này là XGBoost với bốn phương pháp giảm đặc trưng. Dùng toàn bộ 77 đặc trưng thì F1 là 0,9971. SHAP chỉ giữ 30 đặc trưng mà F1 vẫn 0,9970, và thời gian huấn luyện giảm từ 77 phút xuống 20 phút, tức nhanh gấp 3,8 lần. Cùng chọn 30 đặc trưng thì SHAP cho F1 cao hơn RF, 0,9970 so với 0,9922. PCA thì cần 40 thành phần, điểm thấp hơn, và không giải thích được. Vậy SHAP Top-30 là cấu hình chúng tôi chọn.</a:t>
+              <a:t>Nói: Kết quả đầu tiên, trên XGBoost. Ba câu hỏi. Một, bỏ 47 trên 77 đặc trưng thì F1 có giảm không? Gần như không: 0,9971 xuống 0,9970. Hai, huấn luyện có nhanh hơn không? Có, từ 77 phút còn 20 phút, nhanh gấp 3,8 lần. Ba, chọn đặc trưng cách nào tốt nhất? SHAP: cùng 30 đặc trưng, SHAP được 0,9970, RF chỉ 0,9922. PCA cần 40 thành phần, điểm thấp hơn và không giải thích được. Vậy chúng tôi chọn SHAP Top-30.</a:t>
             </a:r>
           </a:p>
           <a:p/>
@@ -1406,7 +1406,7 @@
           <a:lstStyle/>
           <a:p>
             <a:r>
-              <a:t>Nói: Kết quả thứ hai: cổng đích làm tăng điểm đến mức nào. Mỗi thuật toán được huấn luyện hai lần, một lần bỏ cổng và một lần giữ cổng. Với bốn mô hình cây, giữ cổng chỉ tăng F1 chưa tới 0,002. Với hai mô hình tuyến tính thì tăng khoảng 0,04, tức gấp hơn 20 lần. Bài học là đo rò rỉ trên một mô hình thì không suy ra được cho mô hình khác. Từ đây trở đi, mọi kết quả đều đã bỏ cổng.</a:t>
+              <a:t>Nói: Kết quả thứ hai: cổng đích làm tăng điểm bao nhiêu. Mỗi thuật toán được huấn luyện hai lần, bỏ cổng và giữ cổng. Một, mô hình cây có dựa vào cổng không? Hầu như không, F1 tăng chưa tới 0,002. Hai, mô hình tuyến tính thì sao? Dựa nhiều, tăng khoảng 0,04, gấp hơn 20 lần. Ba, đo trên một mô hình có đủ không? Không: nếu chỉ đo Random Forest như bản nộp đầu, ta thấy tăng 0,001 và tưởng rò rỉ không đáng kể. Từ đây trở đi, mọi kết quả đều đã bỏ cổng.</a:t>
             </a:r>
           </a:p>
           <a:p/>

</xml_diff>

<commit_message>
output: FAIR Vietnamese .pptx at 600 dpi with the number-card conclusion
</commit_message>
<xml_diff>
--- a/output/pdfs/FAIR2026_slides_vi.pptx
+++ b/output/pdfs/FAIR2026_slides_vi.pptx
@@ -816,13 +816,13 @@
           <a:lstStyle/>
           <a:p>
             <a:r>
-              <a:t>Nói: Tóm lại, bốn câu hỏi. Một, bỏ bớt đặc trưng được không? Được: bỏ 60%, SHAP Top-30 tương đương 77 đặc trưng về mặt thống kê, và huấn luyện nhanh gấp 3,8 lần. Hai, điểm tổng cao có đủ tin không? Không: điểm chung 0,998, nhưng tính đều từng lớp chỉ 0,806. Ba, sang mạng khác mô hình còn dùng được không? Không: F1 rơi xuống 0,03 đến 0,30, và một lần chạy không đủ tin. Bốn, vậy sang mạng mới làm gì? Gán nhãn 1% dữ liệu của mạng đó rồi huấn luyện lại, F1 lên 0,92 và 0,99. Bài học chung: đánh giá đúng cách quan trọng không kém chọn đúng phương pháp. Xin cảm ơn quý thầy cô, kính mời câu hỏi.</a:t>
+              <a:t>Nói: Tóm lại có bốn con số cần nhớ. Một, 60%: bỏ được 60% đặc trưng mà F1 vẫn tương đương, huấn luyện nhanh gấp 3,8 lần. Hai, từ 0,998 xuống 0,806: điểm tổng cao che khuất các tấn công hiếm. Ba, từ 0,995 xuống còn 0,03 đến 0,30: sang mạng khác, mô hình bỏ sót gần hết tấn công. Bốn, 1%: gán nhãn 1% dữ liệu của mạng mới là đủ để huấn luyện lại. Bài học chung: đánh giá đúng cách quan trọng không kém chọn đúng phương pháp. Xin cảm ơn quý thầy cô, kính mời câu hỏi.</a:t>
             </a:r>
           </a:p>
           <a:p/>
           <a:p>
             <a:r>
-              <a:t>Nếu bị hỏi: Các bộ mới hơn: RoEduNet, CIC-IoT. Tăng số lần lặp bằng kiểm định chéo lồng cũng là hướng củng cố.</a:t>
+              <a:t>Nếu bị hỏi: Hướng tiếp theo: đo riêng tác động của bước bỏ trùng lặp; toàn bộ CSE-CIC- IDS2018 và các bộ mới hơn (RoEduNet, CIC-IoT); thử bộ 30 đặc trưng SHAP trên bộ dữ liệu khác. Tăng số lần lặp bằng kiểm định chéo lồng cũng là hướng củng cố.</a:t>
             </a:r>
           </a:p>
         </p:txBody>

</xml_diff>

<commit_message>
output: FAIR Vietnamese .pptx re-exported with the 1% labelled-data wording
</commit_message>
<xml_diff>
--- a/output/pdfs/FAIR2026_slides_vi.pptx
+++ b/output/pdfs/FAIR2026_slides_vi.pptx
@@ -740,13 +740,13 @@
           <a:lstStyle/>
           <a:p>
             <a:r>
-              <a:t>Nói: Vậy làm sao cho mô hình chạy được trên mạng mới? Một, chỉ chỉnh phân phối dữ liệu cho giống dữ liệu cũ, không cần nhãn, có được không? Không: F1 về 0 ở cả hai chiều. Hai, nếu gán nhãn thì cần bao nhiêu? Rất ít: 1%, khoảng 19 nghìn luồng, huấn luyện lại thì F1 lên 0,92 và 0,99. Ba, gộp thêm toàn bộ dữ liệu cũ có tốt hơn không? Không, lại kém hơn: 0,80 và 0,96. Vậy cách rẻ nhất là gán nhãn một ít lưu lượng của chính mạng mới.</a:t>
+              <a:t>Nói: Vậy làm sao cho mô hình chạy được trên mạng mới? Một, chỉ chỉnh phân phối dữ liệu cho giống dữ liệu cũ, không cần nhãn, có được không? Không: F1 về 0 ở cả hai chiều. Hai, cần bao nhiêu dữ liệu có nhãn của mạng mới? Rất ít: 1%, khoảng 19 nghìn luồng, huấn luyện lại thì F1 lên 0,92 và 0,99. Ba, gộp thêm toàn bộ dữ liệu cũ có tốt hơn không? Không, lại kém hơn: 0,80 và 0,96. Vậy cách rẻ nhất là gán nhãn một ít lưu lượng của chính mạng mới.</a:t>
             </a:r>
           </a:p>
           <a:p/>
           <a:p>
             <a:r>
-              <a:t>Nếu bị hỏi: Reﬁt scaler và CORAL không cần nhãn, không huấn luyện lại, và cho F1 bằng 0 ở cả hai chiều, trong cả 3 lần chạy: dịch chuyển nằm ở phân phối có điều kiện, không chỉ ở trung bình và hiệp phương sai. CORAL vẫn nâng AUC-PR chiều 2018→2017 từ 0,179 lên 0,250: thứ hạng tốt lên nhưng ngưỡng 0,5 học từ dữ liệu cũ không còn đúng, nên thích ứng phải chỉnh cả ngưỡng. 1% là 19.276 luồng (chiều ngược lại 18.011).</a:t>
+              <a:t>Nếu bị hỏi: Reﬁt scaler và CORAL không cần nhãn, không huấn luyện lại, và cho F1 bằng 0 ở cả hai chiều, trong cả 3 lần chạy: dịch chuyển nằm ở phân phối có điều kiện, không chỉ ở trung bình và hiệp phương sai. CORAL vẫn nâng AUC-PR chiều 2018→2017 từ 0,179 lên 0,250: thứ hạng tốt lên nhưng ngưỡng 0,5 học từ dữ liệu cũ không còn đúng, nên thích ứng phải chỉnh cả ngưỡng. 1% là 19.276 luồng (chiều ngược lại 18.011). Trong thí nghiệm, nhãn lấy từ nhãn có sẵn của bộ dữ liệu, lấy 1% tập huấn luyện của bộ đích, mô phỏng việc chuyên viên gán nhãn; mô hình được huấn luyện lại từ đầu chỉ trên phần đó, không tinh chỉnh mô hình cũ. Ngoài thực tế, 19 nghìn luồng vẫn là khối lượng gán nhãn đáng kể nếu làm tay.</a:t>
             </a:r>
           </a:p>
         </p:txBody>
@@ -816,7 +816,7 @@
           <a:lstStyle/>
           <a:p>
             <a:r>
-              <a:t>Nói: Tóm lại có bốn con số cần nhớ. Một, 60%: bỏ được 60% đặc trưng mà F1 vẫn tương đương, huấn luyện nhanh gấp 3,8 lần. Hai, từ 0,998 xuống 0,806: điểm tổng cao che khuất các tấn công hiếm. Ba, từ 0,995 xuống còn 0,03 đến 0,30: sang mạng khác, mô hình bỏ sót gần hết tấn công. Bốn, 1%: gán nhãn 1% dữ liệu của mạng mới là đủ để huấn luyện lại. Bài học chung: đánh giá đúng cách quan trọng không kém chọn đúng phương pháp. Xin cảm ơn quý thầy cô, kính mời câu hỏi.</a:t>
+              <a:t>Nói: Tóm lại có bốn con số cần nhớ. Một, 60%: bỏ được 60% đặc trưng mà F1 vẫn tương đương, huấn luyện nhanh gấp 3,8 lần. Hai, từ 0,998 xuống 0,806: điểm tổng cao che khuất các tấn công hiếm. Ba, từ 0,995 xuống còn 0,03 đến 0,30: sang mạng khác, mô hình bỏ sót gần hết tấn công. Bốn, 1%: chỉ cần 1% dữ liệu có nhãn của mạng mới, khoảng 19 nghìn luồng, để huấn luyện lại. Bài học chung: đánh giá đúng cách quan trọng không kém chọn đúng phương pháp. Xin cảm ơn quý thầy cô, kính mời câu hỏi.</a:t>
             </a:r>
           </a:p>
           <a:p/>

</xml_diff>

<commit_message>
output: FAIR Vietnamese .pptx as saved in PowerPoint before the talk
Same slide text, notes and media as fa3ca6d; PowerPoint 16 rewrote the
document metadata and added empty group transforms.
</commit_message>
<xml_diff>
--- a/output/pdfs/FAIR2026_slides_vi.pptx
+++ b/output/pdfs/FAIR2026_slides_vi.pptx
@@ -4,26 +4,29 @@
   <p:sldMasterIdLst>
     <p:sldMasterId id="2147483648" r:id="rId1"/>
   </p:sldMasterIdLst>
+  <p:notesMasterIdLst>
+    <p:notesMasterId r:id="rId19"/>
+  </p:notesMasterIdLst>
   <p:sldIdLst>
-    <p:sldId id="256" r:id="rId7"/>
-    <p:sldId id="257" r:id="rId9"/>
-    <p:sldId id="258" r:id="rId10"/>
-    <p:sldId id="259" r:id="rId11"/>
-    <p:sldId id="260" r:id="rId12"/>
-    <p:sldId id="261" r:id="rId13"/>
-    <p:sldId id="262" r:id="rId14"/>
-    <p:sldId id="263" r:id="rId15"/>
-    <p:sldId id="264" r:id="rId16"/>
-    <p:sldId id="265" r:id="rId17"/>
-    <p:sldId id="266" r:id="rId18"/>
-    <p:sldId id="267" r:id="rId19"/>
-    <p:sldId id="268" r:id="rId20"/>
-    <p:sldId id="269" r:id="rId21"/>
-    <p:sldId id="270" r:id="rId22"/>
-    <p:sldId id="271" r:id="rId23"/>
-    <p:sldId id="272" r:id="rId24"/>
+    <p:sldId id="256" r:id="rId2"/>
+    <p:sldId id="257" r:id="rId3"/>
+    <p:sldId id="258" r:id="rId4"/>
+    <p:sldId id="259" r:id="rId5"/>
+    <p:sldId id="260" r:id="rId6"/>
+    <p:sldId id="261" r:id="rId7"/>
+    <p:sldId id="262" r:id="rId8"/>
+    <p:sldId id="263" r:id="rId9"/>
+    <p:sldId id="264" r:id="rId10"/>
+    <p:sldId id="265" r:id="rId11"/>
+    <p:sldId id="266" r:id="rId12"/>
+    <p:sldId id="267" r:id="rId13"/>
+    <p:sldId id="268" r:id="rId14"/>
+    <p:sldId id="269" r:id="rId15"/>
+    <p:sldId id="270" r:id="rId16"/>
+    <p:sldId id="271" r:id="rId17"/>
+    <p:sldId id="272" r:id="rId18"/>
   </p:sldIdLst>
-  <p:sldSz cx="5759958" cy="3240024" type="screen4x3"/>
+  <p:sldSz cx="5759450" cy="3240088"/>
   <p:notesSz cx="6858000" cy="9144000"/>
   <p:defaultTextStyle>
     <a:defPPr>
@@ -120,11 +123,27 @@
       </a:defRPr>
     </a:lvl9pPr>
   </p:defaultTextStyle>
+  <p:extLst>
+    <p:ext uri="{EFAFB233-063F-42B5-8137-9DF3F51BA10A}">
+      <p15:sldGuideLst xmlns:p15="http://schemas.microsoft.com/office/powerpoint/2012/main">
+        <p15:guide id="1" orient="horz" pos="2160">
+          <p15:clr>
+            <a:srgbClr val="A4A3A4"/>
+          </p15:clr>
+        </p15:guide>
+        <p15:guide id="2" pos="2880">
+          <p15:clr>
+            <a:srgbClr val="A4A3A4"/>
+          </p15:clr>
+        </p15:guide>
+      </p15:sldGuideLst>
+    </p:ext>
+  </p:extLst>
 </p:presentation>
 </file>
 
 <file path=ppt/notesMasters/notesMaster1.xml><?xml version="1.0" encoding="utf-8"?>
-<p:notesMaster xmlns:a="http://schemas.openxmlformats.org/drawingml/2006/main" xmlns:p="http://schemas.openxmlformats.org/presentationml/2006/main" xmlns:r="http://schemas.openxmlformats.org/officeDocument/2006/relationships">
+<p:notesMaster xmlns:a="http://schemas.openxmlformats.org/drawingml/2006/main" xmlns:r="http://schemas.openxmlformats.org/officeDocument/2006/relationships" xmlns:p="http://schemas.openxmlformats.org/presentationml/2006/main">
   <p:cSld>
     <p:bg>
       <p:bgRef idx="1001">
@@ -145,241 +164,16 @@
           <a:chExt cx="0" cy="0"/>
         </a:xfrm>
       </p:grpSpPr>
-      <p:sp>
-        <p:nvSpPr>
-          <p:cNvPr id="2" name="Header Placeholder 1"/>
-          <p:cNvSpPr>
-            <a:spLocks noGrp="1"/>
-          </p:cNvSpPr>
-          <p:nvPr>
-            <p:ph type="hdr" sz="quarter"/>
-          </p:nvPr>
-        </p:nvSpPr>
-        <p:spPr>
-          <a:xfrm>
-            <a:off x="0" y="0"/>
-            <a:ext cx="2971800" cy="457200"/>
-          </a:xfrm>
-          <a:prstGeom prst="rect">
-            <a:avLst/>
-          </a:prstGeom>
-        </p:spPr>
-        <p:txBody>
-          <a:bodyPr vert="horz" lIns="91440" tIns="45720" rIns="91440" bIns="45720" rtlCol="0"/>
-          <a:lstStyle>
-            <a:lvl1pPr algn="l">
-              <a:defRPr sz="1200"/>
-            </a:lvl1pPr>
-          </a:lstStyle>
-          <a:p>
-            <a:endParaRPr lang="en-US"/>
-          </a:p>
-        </p:txBody>
-      </p:sp>
-      <p:sp>
-        <p:nvSpPr>
-          <p:cNvPr id="3" name="Date Placeholder 2"/>
-          <p:cNvSpPr>
-            <a:spLocks noGrp="1"/>
-          </p:cNvSpPr>
-          <p:nvPr>
-            <p:ph type="dt" idx="1"/>
-          </p:nvPr>
-        </p:nvSpPr>
-        <p:spPr>
-          <a:xfrm>
-            <a:off x="3884613" y="0"/>
-            <a:ext cx="2971800" cy="457200"/>
-          </a:xfrm>
-          <a:prstGeom prst="rect">
-            <a:avLst/>
-          </a:prstGeom>
-        </p:spPr>
-        <p:txBody>
-          <a:bodyPr vert="horz" lIns="91440" tIns="45720" rIns="91440" bIns="45720" rtlCol="0"/>
-          <a:lstStyle>
-            <a:lvl1pPr algn="r">
-              <a:defRPr sz="1200"/>
-            </a:lvl1pPr>
-          </a:lstStyle>
-          <a:p>
-            <a:fld id="{0F89C1C7-3DCD-1040-A9CF-14679D8B5DDD}" type="datetimeFigureOut">
-              <a:rPr lang="en-US" smtClean="0"/>
-              <a:t>10/17/16</a:t>
-            </a:fld>
-            <a:endParaRPr lang="en-US"/>
-          </a:p>
-        </p:txBody>
-      </p:sp>
-      <p:sp>
-        <p:nvSpPr>
-          <p:cNvPr id="4" name="Slide Image Placeholder 3"/>
-          <p:cNvSpPr>
-            <a:spLocks noGrp="1" noRot="1" noChangeAspect="1"/>
-          </p:cNvSpPr>
-          <p:nvPr>
-            <p:ph type="sldImg" idx="2"/>
-          </p:nvPr>
-        </p:nvSpPr>
-        <p:spPr>
-          <a:xfrm>
-            <a:off x="1143000" y="685800"/>
-            <a:ext cx="4572000" cy="3429000"/>
-          </a:xfrm>
-          <a:prstGeom prst="rect">
-            <a:avLst/>
-          </a:prstGeom>
-          <a:noFill/>
-          <a:ln w="12700">
-            <a:solidFill>
-              <a:prstClr val="black"/>
-            </a:solidFill>
-          </a:ln>
-        </p:spPr>
-        <p:txBody>
-          <a:bodyPr vert="horz" lIns="91440" tIns="45720" rIns="91440" bIns="45720" rtlCol="0" anchor="ctr"/>
-          <a:lstStyle/>
-          <a:p>
-            <a:endParaRPr lang="en-US"/>
-          </a:p>
-        </p:txBody>
-      </p:sp>
-      <p:sp>
-        <p:nvSpPr>
-          <p:cNvPr id="5" name="Notes Placeholder 4"/>
-          <p:cNvSpPr>
-            <a:spLocks noGrp="1"/>
-          </p:cNvSpPr>
-          <p:nvPr>
-            <p:ph type="body" sz="quarter" idx="3"/>
-          </p:nvPr>
-        </p:nvSpPr>
-        <p:spPr>
-          <a:xfrm>
-            <a:off x="685800" y="4343400"/>
-            <a:ext cx="5486400" cy="4114800"/>
-          </a:xfrm>
-          <a:prstGeom prst="rect">
-            <a:avLst/>
-          </a:prstGeom>
-        </p:spPr>
-        <p:txBody>
-          <a:bodyPr vert="horz" lIns="91440" tIns="45720" rIns="91440" bIns="45720" rtlCol="0"/>
-          <a:lstStyle/>
-          <a:p>
-            <a:pPr lvl="0"/>
-            <a:r>
-              <a:rPr lang="en-US" smtClean="0"/>
-              <a:t>Click to edit Master text styles</a:t>
-            </a:r>
-          </a:p>
-          <a:p>
-            <a:pPr lvl="1"/>
-            <a:r>
-              <a:rPr lang="en-US" smtClean="0"/>
-              <a:t>Second level</a:t>
-            </a:r>
-          </a:p>
-          <a:p>
-            <a:pPr lvl="2"/>
-            <a:r>
-              <a:rPr lang="en-US" smtClean="0"/>
-              <a:t>Third level</a:t>
-            </a:r>
-          </a:p>
-          <a:p>
-            <a:pPr lvl="3"/>
-            <a:r>
-              <a:rPr lang="en-US" smtClean="0"/>
-              <a:t>Fourth level</a:t>
-            </a:r>
-          </a:p>
-          <a:p>
-            <a:pPr lvl="4"/>
-            <a:r>
-              <a:rPr lang="en-US" smtClean="0"/>
-              <a:t>Fifth level</a:t>
-            </a:r>
-            <a:endParaRPr lang="en-US"/>
-          </a:p>
-        </p:txBody>
-      </p:sp>
-      <p:sp>
-        <p:nvSpPr>
-          <p:cNvPr id="6" name="Footer Placeholder 5"/>
-          <p:cNvSpPr>
-            <a:spLocks noGrp="1"/>
-          </p:cNvSpPr>
-          <p:nvPr>
-            <p:ph type="ftr" sz="quarter" idx="4"/>
-          </p:nvPr>
-        </p:nvSpPr>
-        <p:spPr>
-          <a:xfrm>
-            <a:off x="0" y="8685213"/>
-            <a:ext cx="2971800" cy="457200"/>
-          </a:xfrm>
-          <a:prstGeom prst="rect">
-            <a:avLst/>
-          </a:prstGeom>
-        </p:spPr>
-        <p:txBody>
-          <a:bodyPr vert="horz" lIns="91440" tIns="45720" rIns="91440" bIns="45720" rtlCol="0" anchor="b"/>
-          <a:lstStyle>
-            <a:lvl1pPr algn="l">
-              <a:defRPr sz="1200"/>
-            </a:lvl1pPr>
-          </a:lstStyle>
-          <a:p>
-            <a:endParaRPr lang="en-US"/>
-          </a:p>
-        </p:txBody>
-      </p:sp>
-      <p:sp>
-        <p:nvSpPr>
-          <p:cNvPr id="7" name="Slide Number Placeholder 6"/>
-          <p:cNvSpPr>
-            <a:spLocks noGrp="1"/>
-          </p:cNvSpPr>
-          <p:nvPr>
-            <p:ph type="sldNum" sz="quarter" idx="5"/>
-          </p:nvPr>
-        </p:nvSpPr>
-        <p:spPr>
-          <a:xfrm>
-            <a:off x="3884613" y="8685213"/>
-            <a:ext cx="2971800" cy="457200"/>
-          </a:xfrm>
-          <a:prstGeom prst="rect">
-            <a:avLst/>
-          </a:prstGeom>
-        </p:spPr>
-        <p:txBody>
-          <a:bodyPr vert="horz" lIns="91440" tIns="45720" rIns="91440" bIns="45720" rtlCol="0" anchor="b"/>
-          <a:lstStyle>
-            <a:lvl1pPr algn="r">
-              <a:defRPr sz="1200"/>
-            </a:lvl1pPr>
-          </a:lstStyle>
-          <a:p>
-            <a:fld id="{BB5E49A5-4136-284D-997B-48E1D791AD67}" type="slidenum">
-              <a:rPr lang="en-US" smtClean="0"/>
-              <a:t>‹#›</a:t>
-            </a:fld>
-            <a:endParaRPr lang="en-US"/>
-          </a:p>
-        </p:txBody>
-      </p:sp>
     </p:spTree>
     <p:extLst>
       <p:ext uri="{BB962C8B-B14F-4D97-AF65-F5344CB8AC3E}">
-        <p14:creationId xmlns:p14="http://schemas.microsoft.com/office/powerpoint/2010/main" val="2623252185"/>
+        <p14:creationId xmlns:p14="http://schemas.microsoft.com/office/powerpoint/2010/main" val="870657499"/>
       </p:ext>
     </p:extLst>
   </p:cSld>
   <p:clrMap bg1="lt1" tx1="dk1" bg2="lt2" tx2="dk2" accent1="accent1" accent2="accent2" accent3="accent3" accent4="accent4" accent5="accent5" accent6="accent6" hlink="hlink" folHlink="folHlink"/>
   <p:notesStyle>
-    <a:lvl1pPr marL="0" algn="l" defTabSz="457200" rtl="0" eaLnBrk="1" latinLnBrk="0" hangingPunct="1">
+    <a:lvl1pPr marL="0" algn="l" defTabSz="914400" rtl="0" eaLnBrk="1" latinLnBrk="0" hangingPunct="1">
       <a:defRPr sz="1200" kern="1200">
         <a:solidFill>
           <a:schemeClr val="tx1"/>
@@ -389,7 +183,7 @@
         <a:cs typeface="+mn-cs"/>
       </a:defRPr>
     </a:lvl1pPr>
-    <a:lvl2pPr marL="457200" algn="l" defTabSz="457200" rtl="0" eaLnBrk="1" latinLnBrk="0" hangingPunct="1">
+    <a:lvl2pPr marL="457200" algn="l" defTabSz="914400" rtl="0" eaLnBrk="1" latinLnBrk="0" hangingPunct="1">
       <a:defRPr sz="1200" kern="1200">
         <a:solidFill>
           <a:schemeClr val="tx1"/>
@@ -399,7 +193,7 @@
         <a:cs typeface="+mn-cs"/>
       </a:defRPr>
     </a:lvl2pPr>
-    <a:lvl3pPr marL="914400" algn="l" defTabSz="457200" rtl="0" eaLnBrk="1" latinLnBrk="0" hangingPunct="1">
+    <a:lvl3pPr marL="914400" algn="l" defTabSz="914400" rtl="0" eaLnBrk="1" latinLnBrk="0" hangingPunct="1">
       <a:defRPr sz="1200" kern="1200">
         <a:solidFill>
           <a:schemeClr val="tx1"/>
@@ -409,7 +203,7 @@
         <a:cs typeface="+mn-cs"/>
       </a:defRPr>
     </a:lvl3pPr>
-    <a:lvl4pPr marL="1371600" algn="l" defTabSz="457200" rtl="0" eaLnBrk="1" latinLnBrk="0" hangingPunct="1">
+    <a:lvl4pPr marL="1371600" algn="l" defTabSz="914400" rtl="0" eaLnBrk="1" latinLnBrk="0" hangingPunct="1">
       <a:defRPr sz="1200" kern="1200">
         <a:solidFill>
           <a:schemeClr val="tx1"/>
@@ -419,7 +213,7 @@
         <a:cs typeface="+mn-cs"/>
       </a:defRPr>
     </a:lvl4pPr>
-    <a:lvl5pPr marL="1828800" algn="l" defTabSz="457200" rtl="0" eaLnBrk="1" latinLnBrk="0" hangingPunct="1">
+    <a:lvl5pPr marL="1828800" algn="l" defTabSz="914400" rtl="0" eaLnBrk="1" latinLnBrk="0" hangingPunct="1">
       <a:defRPr sz="1200" kern="1200">
         <a:solidFill>
           <a:schemeClr val="tx1"/>
@@ -429,7 +223,7 @@
         <a:cs typeface="+mn-cs"/>
       </a:defRPr>
     </a:lvl5pPr>
-    <a:lvl6pPr marL="2286000" algn="l" defTabSz="457200" rtl="0" eaLnBrk="1" latinLnBrk="0" hangingPunct="1">
+    <a:lvl6pPr marL="2286000" algn="l" defTabSz="914400" rtl="0" eaLnBrk="1" latinLnBrk="0" hangingPunct="1">
       <a:defRPr sz="1200" kern="1200">
         <a:solidFill>
           <a:schemeClr val="tx1"/>
@@ -439,7 +233,7 @@
         <a:cs typeface="+mn-cs"/>
       </a:defRPr>
     </a:lvl6pPr>
-    <a:lvl7pPr marL="2743200" algn="l" defTabSz="457200" rtl="0" eaLnBrk="1" latinLnBrk="0" hangingPunct="1">
+    <a:lvl7pPr marL="2743200" algn="l" defTabSz="914400" rtl="0" eaLnBrk="1" latinLnBrk="0" hangingPunct="1">
       <a:defRPr sz="1200" kern="1200">
         <a:solidFill>
           <a:schemeClr val="tx1"/>
@@ -449,7 +243,7 @@
         <a:cs typeface="+mn-cs"/>
       </a:defRPr>
     </a:lvl7pPr>
-    <a:lvl8pPr marL="3200400" algn="l" defTabSz="457200" rtl="0" eaLnBrk="1" latinLnBrk="0" hangingPunct="1">
+    <a:lvl8pPr marL="3200400" algn="l" defTabSz="914400" rtl="0" eaLnBrk="1" latinLnBrk="0" hangingPunct="1">
       <a:defRPr sz="1200" kern="1200">
         <a:solidFill>
           <a:schemeClr val="tx1"/>
@@ -459,7 +253,7 @@
         <a:cs typeface="+mn-cs"/>
       </a:defRPr>
     </a:lvl8pPr>
-    <a:lvl9pPr marL="3657600" algn="l" defTabSz="457200" rtl="0" eaLnBrk="1" latinLnBrk="0" hangingPunct="1">
+    <a:lvl9pPr marL="3657600" algn="l" defTabSz="914400" rtl="0" eaLnBrk="1" latinLnBrk="0" hangingPunct="1">
       <a:defRPr sz="1200" kern="1200">
         <a:solidFill>
           <a:schemeClr val="tx1"/>
@@ -474,7 +268,7 @@
 </file>
 
 <file path=ppt/notesSlides/notesSlide1.xml><?xml version="1.0" encoding="utf-8"?>
-<p:notes xmlns:a="http://schemas.openxmlformats.org/drawingml/2006/main" xmlns:p="http://schemas.openxmlformats.org/presentationml/2006/main" xmlns:r="http://schemas.openxmlformats.org/officeDocument/2006/relationships">
+<p:notes xmlns:a="http://schemas.openxmlformats.org/drawingml/2006/main" xmlns:r="http://schemas.openxmlformats.org/officeDocument/2006/relationships" xmlns:p="http://schemas.openxmlformats.org/presentationml/2006/main">
   <p:cSld>
     <p:spTree>
       <p:nvGrpSpPr>
@@ -494,7 +288,7 @@
         <p:nvSpPr>
           <p:cNvPr id="2" name="Slide Image Placeholder 1"/>
           <p:cNvSpPr>
-            <a:spLocks noGrp="1"/>
+            <a:spLocks noGrp="1" noRot="1" noChangeAspect="1"/>
           </p:cNvSpPr>
           <p:nvPr>
             <p:ph type="sldImg" idx="2"/>
@@ -509,7 +303,7 @@
             <a:spLocks noGrp="1"/>
           </p:cNvSpPr>
           <p:nvPr>
-            <p:ph type="body" idx="3" sz="quarter"/>
+            <p:ph type="body" sz="quarter" idx="3"/>
           </p:nvPr>
         </p:nvSpPr>
         <p:spPr/>
@@ -530,7 +324,7 @@
             <a:spLocks noGrp="1"/>
           </p:cNvSpPr>
           <p:nvPr>
-            <p:ph type="sldNum" idx="5" sz="quarter"/>
+            <p:ph type="sldNum" sz="quarter" idx="5"/>
           </p:nvPr>
         </p:nvSpPr>
         <p:spPr/>
@@ -544,7 +338,7 @@
 </file>
 
 <file path=ppt/notesSlides/notesSlide10.xml><?xml version="1.0" encoding="utf-8"?>
-<p:notes xmlns:a="http://schemas.openxmlformats.org/drawingml/2006/main" xmlns:p="http://schemas.openxmlformats.org/presentationml/2006/main" xmlns:r="http://schemas.openxmlformats.org/officeDocument/2006/relationships">
+<p:notes xmlns:a="http://schemas.openxmlformats.org/drawingml/2006/main" xmlns:r="http://schemas.openxmlformats.org/officeDocument/2006/relationships" xmlns:p="http://schemas.openxmlformats.org/presentationml/2006/main">
   <p:cSld>
     <p:spTree>
       <p:nvGrpSpPr>
@@ -564,7 +358,7 @@
         <p:nvSpPr>
           <p:cNvPr id="2" name="Slide Image Placeholder 1"/>
           <p:cNvSpPr>
-            <a:spLocks noGrp="1"/>
+            <a:spLocks noGrp="1" noRot="1" noChangeAspect="1"/>
           </p:cNvSpPr>
           <p:nvPr>
             <p:ph type="sldImg" idx="2"/>
@@ -579,7 +373,7 @@
             <a:spLocks noGrp="1"/>
           </p:cNvSpPr>
           <p:nvPr>
-            <p:ph type="body" idx="3" sz="quarter"/>
+            <p:ph type="body" sz="quarter" idx="3"/>
           </p:nvPr>
         </p:nvSpPr>
         <p:spPr/>
@@ -591,7 +385,9 @@
               <a:t>Nói: Đến đây mới chỉ hỏi có tấn công hay không. Giờ hỏi là loại tấn công nào. Một, điểm tổng có phản ánh đúng không? Không: điểm chung là 0,998, nhưng tính đều cho từng lớp thì chỉ còn 0,806. Hai, lớp nào bị bỏ sót? Các lớp hiếm: cả 6 mẫu SQL Injection và 54% Bot bị xếp là bình thường. Ba, XSS chỉ phát hiện đúng 2,7%, có phải bỏ sót không? Phần lớn không: 76% XSS vẫn bị báo là tấn công, chỉ nhầm sang loại khác. Bỏ sót mới là lỗi nghiêm trọng.</a:t>
             </a:r>
           </a:p>
-          <a:p/>
+          <a:p>
+            <a:endParaRPr/>
+          </a:p>
           <a:p>
             <a:r>
               <a:t>Nếu bị hỏi: Tỉ lệ phát hiện là recall. Mô hình là Random Forest dùng đủ 77 đặc trưng. So sánh các cách giảm đặc trưng ở chế độ đa lớp là hướng tiếp theo. 0,998 là weighted-F1, 0,806 là macro-F1. Ma trận nhầm lẫn ở slide dự phòng. XSS: 81/111 mẫu bị dự đoán là Web Brute Force. Bot 158/290 và 27% Brute Force bị dự đoán là Benign. Nguyên nhân có thể: mất cân bằng cực độ (6–311 mẫu so với 380 nghìn Benign), bỏ cổng rồi thì luồng HTTP ngắn của tấn công web giống lưu lượng duyệt web thông thường, và Bot C&amp;C giống lưu lượng nền.</a:t>
@@ -606,7 +402,7 @@
             <a:spLocks noGrp="1"/>
           </p:cNvSpPr>
           <p:nvPr>
-            <p:ph type="sldNum" idx="5" sz="quarter"/>
+            <p:ph type="sldNum" sz="quarter" idx="5"/>
           </p:nvPr>
         </p:nvSpPr>
         <p:spPr/>
@@ -620,7 +416,7 @@
 </file>
 
 <file path=ppt/notesSlides/notesSlide11.xml><?xml version="1.0" encoding="utf-8"?>
-<p:notes xmlns:a="http://schemas.openxmlformats.org/drawingml/2006/main" xmlns:p="http://schemas.openxmlformats.org/presentationml/2006/main" xmlns:r="http://schemas.openxmlformats.org/officeDocument/2006/relationships">
+<p:notes xmlns:a="http://schemas.openxmlformats.org/drawingml/2006/main" xmlns:r="http://schemas.openxmlformats.org/officeDocument/2006/relationships" xmlns:p="http://schemas.openxmlformats.org/presentationml/2006/main">
   <p:cSld>
     <p:spTree>
       <p:nvGrpSpPr>
@@ -640,7 +436,7 @@
         <p:nvSpPr>
           <p:cNvPr id="2" name="Slide Image Placeholder 1"/>
           <p:cNvSpPr>
-            <a:spLocks noGrp="1"/>
+            <a:spLocks noGrp="1" noRot="1" noChangeAspect="1"/>
           </p:cNvSpPr>
           <p:nvPr>
             <p:ph type="sldImg" idx="2"/>
@@ -655,7 +451,7 @@
             <a:spLocks noGrp="1"/>
           </p:cNvSpPr>
           <p:nvPr>
-            <p:ph type="body" idx="3" sz="quarter"/>
+            <p:ph type="body" sz="quarter" idx="3"/>
           </p:nvPr>
         </p:nvSpPr>
         <p:spPr/>
@@ -667,7 +463,9 @@
               <a:t>Nói: Đây là kết quả quan trọng nhất. Một, sang mạng khác mô hình còn tốt không? Không: cùng bộ thì F1 là 0,995, sang bộ 2018 chỉ còn 0,03 đến 0,30. Chiều ngược lại, 0,925 còn 0,05. Hai, mô hình sai kiểu gì? Bỏ sót: chỉ phát hiện được 7% và 3% số tấn công. Ba, một lần chạy có đủ tin không? Không. Hình bên phải: 18 lần chạy cùng mã, cùng dữ liệu, F1 rơi vào hai cụm, 11 lần thấp, 7 lần cao, không lần nào ở giữa. Nên chúng tôi báo cả 18 lần và so sánh thêm bằng AUC-PR, là điểm không phụ thuộc ngưỡng nên ổn định hơn F1.</a:t>
             </a:r>
           </a:p>
-          <a:p/>
+          <a:p>
+            <a:endParaRPr/>
+          </a:p>
           <a:p>
             <a:r>
               <a:t>Nếu bị hỏi: AUC-PR không phụ thuộc ngưỡng, giảm từ 0,9997 xuống 0,4849 (trung bình 18 lần) và từ 0,9679 xuống 0,1926. Recall 0,073 / 0,030, precision 0,772 / 0,272: mô hình bỏ sót chứ không báo động giả nhiều. Hai cụm có AUC-PR như nhau (Welch |t| = 1,3): thứ hạng không đổi, chỉ có ngưỡng 0,5 cắt qua một cụm luồng gần giống nhau. Năm seed chạy lại, hai lần đổi cụm. Nguyên nhân dịch chuyển: khác phiên bản CICFlowMeter, cấu hình mạng, công cụ tấn công. Xem slide dự phòng.</a:t>
@@ -682,7 +480,7 @@
             <a:spLocks noGrp="1"/>
           </p:cNvSpPr>
           <p:nvPr>
-            <p:ph type="sldNum" idx="5" sz="quarter"/>
+            <p:ph type="sldNum" sz="quarter" idx="5"/>
           </p:nvPr>
         </p:nvSpPr>
         <p:spPr/>
@@ -696,7 +494,7 @@
 </file>
 
 <file path=ppt/notesSlides/notesSlide12.xml><?xml version="1.0" encoding="utf-8"?>
-<p:notes xmlns:a="http://schemas.openxmlformats.org/drawingml/2006/main" xmlns:p="http://schemas.openxmlformats.org/presentationml/2006/main" xmlns:r="http://schemas.openxmlformats.org/officeDocument/2006/relationships">
+<p:notes xmlns:a="http://schemas.openxmlformats.org/drawingml/2006/main" xmlns:r="http://schemas.openxmlformats.org/officeDocument/2006/relationships" xmlns:p="http://schemas.openxmlformats.org/presentationml/2006/main">
   <p:cSld>
     <p:spTree>
       <p:nvGrpSpPr>
@@ -716,7 +514,7 @@
         <p:nvSpPr>
           <p:cNvPr id="2" name="Slide Image Placeholder 1"/>
           <p:cNvSpPr>
-            <a:spLocks noGrp="1"/>
+            <a:spLocks noGrp="1" noRot="1" noChangeAspect="1"/>
           </p:cNvSpPr>
           <p:nvPr>
             <p:ph type="sldImg" idx="2"/>
@@ -731,7 +529,7 @@
             <a:spLocks noGrp="1"/>
           </p:cNvSpPr>
           <p:nvPr>
-            <p:ph type="body" idx="3" sz="quarter"/>
+            <p:ph type="body" sz="quarter" idx="3"/>
           </p:nvPr>
         </p:nvSpPr>
         <p:spPr/>
@@ -743,7 +541,9 @@
               <a:t>Nói: Vậy làm sao cho mô hình chạy được trên mạng mới? Một, chỉ chỉnh phân phối dữ liệu cho giống dữ liệu cũ, không cần nhãn, có được không? Không: F1 về 0 ở cả hai chiều. Hai, cần bao nhiêu dữ liệu có nhãn của mạng mới? Rất ít: 1%, khoảng 19 nghìn luồng, huấn luyện lại thì F1 lên 0,92 và 0,99. Ba, gộp thêm toàn bộ dữ liệu cũ có tốt hơn không? Không, lại kém hơn: 0,80 và 0,96. Vậy cách rẻ nhất là gán nhãn một ít lưu lượng của chính mạng mới.</a:t>
             </a:r>
           </a:p>
-          <a:p/>
+          <a:p>
+            <a:endParaRPr/>
+          </a:p>
           <a:p>
             <a:r>
               <a:t>Nếu bị hỏi: Reﬁt scaler và CORAL không cần nhãn, không huấn luyện lại, và cho F1 bằng 0 ở cả hai chiều, trong cả 3 lần chạy: dịch chuyển nằm ở phân phối có điều kiện, không chỉ ở trung bình và hiệp phương sai. CORAL vẫn nâng AUC-PR chiều 2018→2017 từ 0,179 lên 0,250: thứ hạng tốt lên nhưng ngưỡng 0,5 học từ dữ liệu cũ không còn đúng, nên thích ứng phải chỉnh cả ngưỡng. 1% là 19.276 luồng (chiều ngược lại 18.011). Trong thí nghiệm, nhãn lấy từ nhãn có sẵn của bộ dữ liệu, lấy 1% tập huấn luyện của bộ đích, mô phỏng việc chuyên viên gán nhãn; mô hình được huấn luyện lại từ đầu chỉ trên phần đó, không tinh chỉnh mô hình cũ. Ngoài thực tế, 19 nghìn luồng vẫn là khối lượng gán nhãn đáng kể nếu làm tay. “Mạng mới” là bộ dữ liệu đích: CSE-CIC-IDS2018 khi huấn luyện trên CICIDS2017, và ngược lại. Cả hai đều là testbed trong phòng thí nghiệm của CIC, không phải lưu lượng của một mạng doanh nghiệp thật, nên kết quả 1% mới được chứng minh giữa hai testbed này.</a:t>
@@ -758,7 +558,7 @@
             <a:spLocks noGrp="1"/>
           </p:cNvSpPr>
           <p:nvPr>
-            <p:ph type="sldNum" idx="5" sz="quarter"/>
+            <p:ph type="sldNum" sz="quarter" idx="5"/>
           </p:nvPr>
         </p:nvSpPr>
         <p:spPr/>
@@ -772,7 +572,7 @@
 </file>
 
 <file path=ppt/notesSlides/notesSlide13.xml><?xml version="1.0" encoding="utf-8"?>
-<p:notes xmlns:a="http://schemas.openxmlformats.org/drawingml/2006/main" xmlns:p="http://schemas.openxmlformats.org/presentationml/2006/main" xmlns:r="http://schemas.openxmlformats.org/officeDocument/2006/relationships">
+<p:notes xmlns:a="http://schemas.openxmlformats.org/drawingml/2006/main" xmlns:r="http://schemas.openxmlformats.org/officeDocument/2006/relationships" xmlns:p="http://schemas.openxmlformats.org/presentationml/2006/main">
   <p:cSld>
     <p:spTree>
       <p:nvGrpSpPr>
@@ -792,7 +592,7 @@
         <p:nvSpPr>
           <p:cNvPr id="2" name="Slide Image Placeholder 1"/>
           <p:cNvSpPr>
-            <a:spLocks noGrp="1"/>
+            <a:spLocks noGrp="1" noRot="1" noChangeAspect="1"/>
           </p:cNvSpPr>
           <p:nvPr>
             <p:ph type="sldImg" idx="2"/>
@@ -807,7 +607,7 @@
             <a:spLocks noGrp="1"/>
           </p:cNvSpPr>
           <p:nvPr>
-            <p:ph type="body" idx="3" sz="quarter"/>
+            <p:ph type="body" sz="quarter" idx="3"/>
           </p:nvPr>
         </p:nvSpPr>
         <p:spPr/>
@@ -819,7 +619,9 @@
               <a:t>Nói: Tóm lại có bốn con số cần nhớ. Một, 60%: bỏ được 60% đặc trưng mà F1 vẫn tương đương, huấn luyện nhanh gấp 3,8 lần. Hai, từ 0,998 xuống 0,806: điểm tổng cao che khuất các tấn công hiếm. Ba, từ 0,995 xuống còn 0,03 đến 0,30: sang mạng khác, mô hình bỏ sót gần hết tấn công. Bốn, 1%: chỉ cần 1% dữ liệu có nhãn của mạng mới, khoảng 19 nghìn luồng, để huấn luyện lại. Bài học chung: đánh giá đúng cách quan trọng không kém chọn đúng phương pháp. Xin cảm ơn quý thầy cô, kính mời câu hỏi.</a:t>
             </a:r>
           </a:p>
-          <a:p/>
+          <a:p>
+            <a:endParaRPr/>
+          </a:p>
           <a:p>
             <a:r>
               <a:t>Nếu bị hỏi: Hướng tiếp theo: đo riêng tác động của bước bỏ trùng lặp; toàn bộ CSE-CIC- IDS2018 và các bộ mới hơn (RoEduNet, CIC-IoT); thử bộ 30 đặc trưng SHAP trên bộ dữ liệu khác. Tăng số lần lặp bằng kiểm định chéo lồng cũng là hướng củng cố.</a:t>
@@ -834,7 +636,7 @@
             <a:spLocks noGrp="1"/>
           </p:cNvSpPr>
           <p:nvPr>
-            <p:ph type="sldNum" idx="5" sz="quarter"/>
+            <p:ph type="sldNum" sz="quarter" idx="5"/>
           </p:nvPr>
         </p:nvSpPr>
         <p:spPr/>
@@ -848,7 +650,7 @@
 </file>
 
 <file path=ppt/notesSlides/notesSlide14.xml><?xml version="1.0" encoding="utf-8"?>
-<p:notes xmlns:a="http://schemas.openxmlformats.org/drawingml/2006/main" xmlns:p="http://schemas.openxmlformats.org/presentationml/2006/main" xmlns:r="http://schemas.openxmlformats.org/officeDocument/2006/relationships">
+<p:notes xmlns:a="http://schemas.openxmlformats.org/drawingml/2006/main" xmlns:r="http://schemas.openxmlformats.org/officeDocument/2006/relationships" xmlns:p="http://schemas.openxmlformats.org/presentationml/2006/main">
   <p:cSld>
     <p:spTree>
       <p:nvGrpSpPr>
@@ -868,7 +670,7 @@
         <p:nvSpPr>
           <p:cNvPr id="2" name="Slide Image Placeholder 1"/>
           <p:cNvSpPr>
-            <a:spLocks noGrp="1"/>
+            <a:spLocks noGrp="1" noRot="1" noChangeAspect="1"/>
           </p:cNvSpPr>
           <p:nvPr>
             <p:ph type="sldImg" idx="2"/>
@@ -883,7 +685,7 @@
             <a:spLocks noGrp="1"/>
           </p:cNvSpPr>
           <p:nvPr>
-            <p:ph type="body" idx="3" sz="quarter"/>
+            <p:ph type="body" sz="quarter" idx="3"/>
           </p:nvPr>
         </p:nvSpPr>
         <p:spPr/>
@@ -904,7 +706,7 @@
             <a:spLocks noGrp="1"/>
           </p:cNvSpPr>
           <p:nvPr>
-            <p:ph type="sldNum" idx="5" sz="quarter"/>
+            <p:ph type="sldNum" sz="quarter" idx="5"/>
           </p:nvPr>
         </p:nvSpPr>
         <p:spPr/>
@@ -918,7 +720,7 @@
 </file>
 
 <file path=ppt/notesSlides/notesSlide2.xml><?xml version="1.0" encoding="utf-8"?>
-<p:notes xmlns:a="http://schemas.openxmlformats.org/drawingml/2006/main" xmlns:p="http://schemas.openxmlformats.org/presentationml/2006/main" xmlns:r="http://schemas.openxmlformats.org/officeDocument/2006/relationships">
+<p:notes xmlns:a="http://schemas.openxmlformats.org/drawingml/2006/main" xmlns:r="http://schemas.openxmlformats.org/officeDocument/2006/relationships" xmlns:p="http://schemas.openxmlformats.org/presentationml/2006/main">
   <p:cSld>
     <p:spTree>
       <p:nvGrpSpPr>
@@ -938,7 +740,7 @@
         <p:nvSpPr>
           <p:cNvPr id="2" name="Slide Image Placeholder 1"/>
           <p:cNvSpPr>
-            <a:spLocks noGrp="1"/>
+            <a:spLocks noGrp="1" noRot="1" noChangeAspect="1"/>
           </p:cNvSpPr>
           <p:nvPr>
             <p:ph type="sldImg" idx="2"/>
@@ -953,7 +755,7 @@
             <a:spLocks noGrp="1"/>
           </p:cNvSpPr>
           <p:nvPr>
-            <p:ph type="body" idx="3" sz="quarter"/>
+            <p:ph type="body" sz="quarter" idx="3"/>
           </p:nvPr>
         </p:nvSpPr>
         <p:spPr/>
@@ -974,7 +776,7 @@
             <a:spLocks noGrp="1"/>
           </p:cNvSpPr>
           <p:nvPr>
-            <p:ph type="sldNum" idx="5" sz="quarter"/>
+            <p:ph type="sldNum" sz="quarter" idx="5"/>
           </p:nvPr>
         </p:nvSpPr>
         <p:spPr/>
@@ -988,7 +790,7 @@
 </file>
 
 <file path=ppt/notesSlides/notesSlide3.xml><?xml version="1.0" encoding="utf-8"?>
-<p:notes xmlns:a="http://schemas.openxmlformats.org/drawingml/2006/main" xmlns:p="http://schemas.openxmlformats.org/presentationml/2006/main" xmlns:r="http://schemas.openxmlformats.org/officeDocument/2006/relationships">
+<p:notes xmlns:a="http://schemas.openxmlformats.org/drawingml/2006/main" xmlns:r="http://schemas.openxmlformats.org/officeDocument/2006/relationships" xmlns:p="http://schemas.openxmlformats.org/presentationml/2006/main">
   <p:cSld>
     <p:spTree>
       <p:nvGrpSpPr>
@@ -1008,7 +810,7 @@
         <p:nvSpPr>
           <p:cNvPr id="2" name="Slide Image Placeholder 1"/>
           <p:cNvSpPr>
-            <a:spLocks noGrp="1"/>
+            <a:spLocks noGrp="1" noRot="1" noChangeAspect="1"/>
           </p:cNvSpPr>
           <p:nvPr>
             <p:ph type="sldImg" idx="2"/>
@@ -1023,7 +825,7 @@
             <a:spLocks noGrp="1"/>
           </p:cNvSpPr>
           <p:nvPr>
-            <p:ph type="body" idx="3" sz="quarter"/>
+            <p:ph type="body" sz="quarter" idx="3"/>
           </p:nvPr>
         </p:nvSpPr>
         <p:spPr/>
@@ -1035,7 +837,9 @@
               <a:t>Nói: Bài báo xuất phát từ hai câu hỏi. Thứ nhất, mỗi luồng mạng có khoảng 80 đặc trưng, có cần dùng hết không, vì càng nhiều thì càng tốn và càng khó chạy trên thiết bị biên. Thứ hai, rất nhiều bài đạt F1 trên 0,99 với bộ dữ liệu này, điểm đó có đáng tin không. Có hai dạng rò rỉ dữ liệu khiến điểm cao hơn thực tế. Rò rỉ dữ liệu, nói đơn giản, là mô hình được biết trước thứ mà khi triển khai thật nó không có. Một là cổng đích: trong bộ dữ liệu, mỗi loại tấn công nhắm vào một số cổng cố định, nên cổng gần như tiết lộ nhãn. Hai là luồng trùng nhau nằm ở cả tập huấn luyện lẫn tập kiểm tra, mô hình xem như đã thấy dữ liệu kiểm tra từ lúc huấn luyện. Vì vậy chúng tôi sửa quy trình đánh giá trước, rồi mới so sánh các phương pháp giảm đặc trưng.</a:t>
             </a:r>
           </a:p>
-          <a:p/>
+          <a:p>
+            <a:endParaRPr/>
+          </a:p>
           <a:p>
             <a:r>
               <a:t>Nếu bị hỏi: Rò rỉ dữ liệu là khi thông tin không có lúc triển khai lọt vào huấn luyện hoặc đánh giá. Cột cổng đích trong dữ liệu là destination_port.</a:t>
@@ -1050,7 +854,7 @@
             <a:spLocks noGrp="1"/>
           </p:cNvSpPr>
           <p:nvPr>
-            <p:ph type="sldNum" idx="5" sz="quarter"/>
+            <p:ph type="sldNum" sz="quarter" idx="5"/>
           </p:nvPr>
         </p:nvSpPr>
         <p:spPr/>
@@ -1064,7 +868,7 @@
 </file>
 
 <file path=ppt/notesSlides/notesSlide4.xml><?xml version="1.0" encoding="utf-8"?>
-<p:notes xmlns:a="http://schemas.openxmlformats.org/drawingml/2006/main" xmlns:p="http://schemas.openxmlformats.org/presentationml/2006/main" xmlns:r="http://schemas.openxmlformats.org/officeDocument/2006/relationships">
+<p:notes xmlns:a="http://schemas.openxmlformats.org/drawingml/2006/main" xmlns:r="http://schemas.openxmlformats.org/officeDocument/2006/relationships" xmlns:p="http://schemas.openxmlformats.org/presentationml/2006/main">
   <p:cSld>
     <p:spTree>
       <p:nvGrpSpPr>
@@ -1084,7 +888,7 @@
         <p:nvSpPr>
           <p:cNvPr id="2" name="Slide Image Placeholder 1"/>
           <p:cNvSpPr>
-            <a:spLocks noGrp="1"/>
+            <a:spLocks noGrp="1" noRot="1" noChangeAspect="1"/>
           </p:cNvSpPr>
           <p:nvPr>
             <p:ph type="sldImg" idx="2"/>
@@ -1099,7 +903,7 @@
             <a:spLocks noGrp="1"/>
           </p:cNvSpPr>
           <p:nvPr>
-            <p:ph type="body" idx="3" sz="quarter"/>
+            <p:ph type="body" sz="quarter" idx="3"/>
           </p:nvPr>
         </p:nvSpPr>
         <p:spPr/>
@@ -1120,7 +924,7 @@
             <a:spLocks noGrp="1"/>
           </p:cNvSpPr>
           <p:nvPr>
-            <p:ph type="sldNum" idx="5" sz="quarter"/>
+            <p:ph type="sldNum" sz="quarter" idx="5"/>
           </p:nvPr>
         </p:nvSpPr>
         <p:spPr/>
@@ -1134,7 +938,7 @@
 </file>
 
 <file path=ppt/notesSlides/notesSlide5.xml><?xml version="1.0" encoding="utf-8"?>
-<p:notes xmlns:a="http://schemas.openxmlformats.org/drawingml/2006/main" xmlns:p="http://schemas.openxmlformats.org/presentationml/2006/main" xmlns:r="http://schemas.openxmlformats.org/officeDocument/2006/relationships">
+<p:notes xmlns:a="http://schemas.openxmlformats.org/drawingml/2006/main" xmlns:r="http://schemas.openxmlformats.org/officeDocument/2006/relationships" xmlns:p="http://schemas.openxmlformats.org/presentationml/2006/main">
   <p:cSld>
     <p:spTree>
       <p:nvGrpSpPr>
@@ -1154,7 +958,7 @@
         <p:nvSpPr>
           <p:cNvPr id="2" name="Slide Image Placeholder 1"/>
           <p:cNvSpPr>
-            <a:spLocks noGrp="1"/>
+            <a:spLocks noGrp="1" noRot="1" noChangeAspect="1"/>
           </p:cNvSpPr>
           <p:nvPr>
             <p:ph type="sldImg" idx="2"/>
@@ -1169,7 +973,7 @@
             <a:spLocks noGrp="1"/>
           </p:cNvSpPr>
           <p:nvPr>
-            <p:ph type="body" idx="3" sz="quarter"/>
+            <p:ph type="body" sz="quarter" idx="3"/>
           </p:nvPr>
         </p:nvSpPr>
         <p:spPr/>
@@ -1181,7 +985,9 @@
               <a:t>Nói: Đây là quy trình, đi từ trên xuống. Hai khối đỏ là hai bước chặn rò rỉ. Trước khi chia dữ liệu, chúng tôi bỏ cổng và bỏ luồng trùng, nên không luồng nào nằm ở cả hai tập. Sau đó áp dụng bốn phương pháp giảm đặc trưng, huấn luyện tám thuật toán. Bảng xếp hạng đặc trưng chỉ tính trên tập huấn luyện. Chọn mô hình thì dùng tập kiểm định, tức tập validation tách từ tập huấn luyện. Tập kiểm tra chỉ dùng một lần, ở cuối. Siêu tham số được cố định từ trước và dùng chung cho cả bốn phương pháp, nên khác biệt là do phương pháp chứ không do tinh chỉnh. Cuối cùng, cấu hình SHAP 30 đặc trưng được đưa xuống thiết bị biên.</a:t>
             </a:r>
           </a:p>
-          <a:p/>
+          <a:p>
+            <a:endParaRPr/>
+          </a:p>
           <a:p>
             <a:r>
               <a:t>Nếu bị hỏi: Tập kiểm định tách 20% từ tập huấn luyện. Bốn cấu hình so sánh được cố định từ trước (toàn bộ 77, RF Top-30, SHAP Top-30, PCA k=40), siêu tham số dùng chung, nên khác biệt phản ánh phương pháp chứ không phải việc tinh chỉnh.</a:t>
@@ -1196,7 +1002,7 @@
             <a:spLocks noGrp="1"/>
           </p:cNvSpPr>
           <p:nvPr>
-            <p:ph type="sldNum" idx="5" sz="quarter"/>
+            <p:ph type="sldNum" sz="quarter" idx="5"/>
           </p:nvPr>
         </p:nvSpPr>
         <p:spPr/>
@@ -1210,7 +1016,7 @@
 </file>
 
 <file path=ppt/notesSlides/notesSlide6.xml><?xml version="1.0" encoding="utf-8"?>
-<p:notes xmlns:a="http://schemas.openxmlformats.org/drawingml/2006/main" xmlns:p="http://schemas.openxmlformats.org/presentationml/2006/main" xmlns:r="http://schemas.openxmlformats.org/officeDocument/2006/relationships">
+<p:notes xmlns:a="http://schemas.openxmlformats.org/drawingml/2006/main" xmlns:r="http://schemas.openxmlformats.org/officeDocument/2006/relationships" xmlns:p="http://schemas.openxmlformats.org/presentationml/2006/main">
   <p:cSld>
     <p:spTree>
       <p:nvGrpSpPr>
@@ -1230,7 +1036,7 @@
         <p:nvSpPr>
           <p:cNvPr id="2" name="Slide Image Placeholder 1"/>
           <p:cNvSpPr>
-            <a:spLocks noGrp="1"/>
+            <a:spLocks noGrp="1" noRot="1" noChangeAspect="1"/>
           </p:cNvSpPr>
           <p:nvPr>
             <p:ph type="sldImg" idx="2"/>
@@ -1245,7 +1051,7 @@
             <a:spLocks noGrp="1"/>
           </p:cNvSpPr>
           <p:nvPr>
-            <p:ph type="body" idx="3" sz="quarter"/>
+            <p:ph type="body" sz="quarter" idx="3"/>
           </p:nvPr>
         </p:nvSpPr>
         <p:spPr/>
@@ -1257,7 +1063,9 @@
               <a:t>Nói: Bỏ luồng trùng nghe đơn giản nhưng dễ làm sai. Những luồng giống hệt nhau ở mọi đặc trưng thì chỉ giữ một bản. Nhưng có những nhóm giống hệt nhau mà nhãn lại khác nhau, vừa bình thường vừa tấn công. Đây là lỗi đã biết của CICIDS2017. Với nhóm như vậy chúng tôi bỏ cả nhóm: 270 nhóm, hơn 44 nghìn luồng. Lý do là nếu giữ ngẫu nhiên một luồng thì mỗi lần chạy ra một bộ dữ liệu khác. Sau khi làm sạch còn 77 đặc trưng, khoảng 1,8 triệu luồng huấn luyện và 450 nghìn luồng kiểm tra.</a:t>
             </a:r>
           </a:p>
-          <a:p/>
+          <a:p>
+            <a:endParaRPr/>
+          </a:p>
           <a:p>
             <a:r>
               <a:t>Nếu bị hỏi: Cột bị bỏ: destination_port, source_port, protocol và các cột định danh. Lỗi nhãn mâu thuẫn đã được Lanvin et al. ghi nhận. CSE-CIC-IDS2018 lấy mẫu phân tầng 20%, được 3,14 triệu luồng, còn 2,39 triệu sau khi bỏ trùng. Spark 3.4.1. Máy chủ chỉ làm master, không chạy executor, nên thời gian huấn luyện là thời gian trên hai Jetson.</a:t>
@@ -1272,7 +1080,7 @@
             <a:spLocks noGrp="1"/>
           </p:cNvSpPr>
           <p:nvPr>
-            <p:ph type="sldNum" idx="5" sz="quarter"/>
+            <p:ph type="sldNum" sz="quarter" idx="5"/>
           </p:nvPr>
         </p:nvSpPr>
         <p:spPr/>
@@ -1286,7 +1094,7 @@
 </file>
 
 <file path=ppt/notesSlides/notesSlide7.xml><?xml version="1.0" encoding="utf-8"?>
-<p:notes xmlns:a="http://schemas.openxmlformats.org/drawingml/2006/main" xmlns:p="http://schemas.openxmlformats.org/presentationml/2006/main" xmlns:r="http://schemas.openxmlformats.org/officeDocument/2006/relationships">
+<p:notes xmlns:a="http://schemas.openxmlformats.org/drawingml/2006/main" xmlns:r="http://schemas.openxmlformats.org/officeDocument/2006/relationships" xmlns:p="http://schemas.openxmlformats.org/presentationml/2006/main">
   <p:cSld>
     <p:spTree>
       <p:nvGrpSpPr>
@@ -1306,7 +1114,7 @@
         <p:nvSpPr>
           <p:cNvPr id="2" name="Slide Image Placeholder 1"/>
           <p:cNvSpPr>
-            <a:spLocks noGrp="1"/>
+            <a:spLocks noGrp="1" noRot="1" noChangeAspect="1"/>
           </p:cNvSpPr>
           <p:nvPr>
             <p:ph type="sldImg" idx="2"/>
@@ -1321,7 +1129,7 @@
             <a:spLocks noGrp="1"/>
           </p:cNvSpPr>
           <p:nvPr>
-            <p:ph type="body" idx="3" sz="quarter"/>
+            <p:ph type="body" sz="quarter" idx="3"/>
           </p:nvPr>
         </p:nvSpPr>
         <p:spPr/>
@@ -1333,7 +1141,9 @@
               <a:t>Nói: Kết quả đầu tiên, trên XGBoost. Ba câu hỏi. Một, bỏ 47 trên 77 đặc trưng thì F1 có giảm không? Gần như không: 0,9971 xuống 0,9970. Hai, huấn luyện có nhanh hơn không? Có, từ 77 phút còn 20 phút, nhanh gấp 3,8 lần. Ba, chọn đặc trưng cách nào tốt nhất? SHAP: cùng 30 đặc trưng, SHAP được 0,9970, RF chỉ 0,9922. PCA cần 40 thành phần, điểm thấp hơn và không giải thích được. Vậy chúng tôi chọn SHAP Top-30.</a:t>
             </a:r>
           </a:p>
-          <a:p/>
+          <a:p>
+            <a:endParaRPr/>
+          </a:p>
           <a:p>
             <a:r>
               <a:t>Nếu bị hỏi: SHAP hơn RF ở cả bốn thuật toán cây, xem slide dự phòng. Thời gian huấn luyện chính xác là 4615,5 s và 1226,1 s, giảm khoảng 73%. PCA dùng k=40 vì nó trích xuất chứ không chọn lọc: mỗi thành phần chỉ mang một phần phương sai.</a:t>
@@ -1348,7 +1158,7 @@
             <a:spLocks noGrp="1"/>
           </p:cNvSpPr>
           <p:nvPr>
-            <p:ph type="sldNum" idx="5" sz="quarter"/>
+            <p:ph type="sldNum" sz="quarter" idx="5"/>
           </p:nvPr>
         </p:nvSpPr>
         <p:spPr/>
@@ -1362,7 +1172,7 @@
 </file>
 
 <file path=ppt/notesSlides/notesSlide8.xml><?xml version="1.0" encoding="utf-8"?>
-<p:notes xmlns:a="http://schemas.openxmlformats.org/drawingml/2006/main" xmlns:p="http://schemas.openxmlformats.org/presentationml/2006/main" xmlns:r="http://schemas.openxmlformats.org/officeDocument/2006/relationships">
+<p:notes xmlns:a="http://schemas.openxmlformats.org/drawingml/2006/main" xmlns:r="http://schemas.openxmlformats.org/officeDocument/2006/relationships" xmlns:p="http://schemas.openxmlformats.org/presentationml/2006/main">
   <p:cSld>
     <p:spTree>
       <p:nvGrpSpPr>
@@ -1382,7 +1192,7 @@
         <p:nvSpPr>
           <p:cNvPr id="2" name="Slide Image Placeholder 1"/>
           <p:cNvSpPr>
-            <a:spLocks noGrp="1"/>
+            <a:spLocks noGrp="1" noRot="1" noChangeAspect="1"/>
           </p:cNvSpPr>
           <p:nvPr>
             <p:ph type="sldImg" idx="2"/>
@@ -1397,7 +1207,7 @@
             <a:spLocks noGrp="1"/>
           </p:cNvSpPr>
           <p:nvPr>
-            <p:ph type="body" idx="3" sz="quarter"/>
+            <p:ph type="body" sz="quarter" idx="3"/>
           </p:nvPr>
         </p:nvSpPr>
         <p:spPr/>
@@ -1409,7 +1219,9 @@
               <a:t>Nói: Kết quả thứ hai: cổng đích làm tăng điểm bao nhiêu. Mỗi thuật toán được huấn luyện hai lần, bỏ cổng và giữ cổng. Một, mô hình cây có dựa vào cổng không? Hầu như không, F1 tăng chưa tới 0,002. Hai, mô hình tuyến tính thì sao? Dựa nhiều, tăng khoảng 0,04, gấp hơn 20 lần. Ba, chỉ đo rò rỉ trên Random Forest có đủ không? Không. Bản nộp đầu chỉ đo trên Random Forest: F1 tăng 0,001, trông như cổng đích không ảnh hưởng gì. Nhưng LR và SVM tăng 0,04. Nên rò rỉ phải đo trên từng mô hình. Từ đây trở đi, mọi kết quả đều đã bỏ cổng.</a:t>
             </a:r>
           </a:p>
-          <a:p/>
+          <a:p>
+            <a:endParaRPr/>
+          </a:p>
           <a:p>
             <a:r>
               <a:t>Nếu bị hỏi: Số từng thuật toán ở slide dự phòng. Mô hình cây dựng lại được cùng ranh giới từ thống kê hành vi của luồng. Mô hình tuyến tính không làm được, nên dựa vào cổng như một định danh dịch vụ. Bản nộp ban đầu chỉ đo trên Random Forest (0,9964 so với 0,9954). Bản camera-ready đo cả tám thuật toán theo góp ý phản biện.</a:t>
@@ -1424,7 +1236,7 @@
             <a:spLocks noGrp="1"/>
           </p:cNvSpPr>
           <p:nvPr>
-            <p:ph type="sldNum" idx="5" sz="quarter"/>
+            <p:ph type="sldNum" sz="quarter" idx="5"/>
           </p:nvPr>
         </p:nvSpPr>
         <p:spPr/>
@@ -1438,7 +1250,7 @@
 </file>
 
 <file path=ppt/notesSlides/notesSlide9.xml><?xml version="1.0" encoding="utf-8"?>
-<p:notes xmlns:a="http://schemas.openxmlformats.org/drawingml/2006/main" xmlns:p="http://schemas.openxmlformats.org/presentationml/2006/main" xmlns:r="http://schemas.openxmlformats.org/officeDocument/2006/relationships">
+<p:notes xmlns:a="http://schemas.openxmlformats.org/drawingml/2006/main" xmlns:r="http://schemas.openxmlformats.org/officeDocument/2006/relationships" xmlns:p="http://schemas.openxmlformats.org/presentationml/2006/main">
   <p:cSld>
     <p:spTree>
       <p:nvGrpSpPr>
@@ -1458,7 +1270,7 @@
         <p:nvSpPr>
           <p:cNvPr id="2" name="Slide Image Placeholder 1"/>
           <p:cNvSpPr>
-            <a:spLocks noGrp="1"/>
+            <a:spLocks noGrp="1" noRot="1" noChangeAspect="1"/>
           </p:cNvSpPr>
           <p:nvPr>
             <p:ph type="sldImg" idx="2"/>
@@ -1473,7 +1285,7 @@
             <a:spLocks noGrp="1"/>
           </p:cNvSpPr>
           <p:nvPr>
-            <p:ph type="body" idx="3" sz="quarter"/>
+            <p:ph type="body" sz="quarter" idx="3"/>
           </p:nvPr>
         </p:nvSpPr>
         <p:spPr/>
@@ -1485,7 +1297,9 @@
               <a:t>Nói: Kết quả 1 chỉ là một lần chạy, nên chúng tôi làm bốn bước. Một, chạy lại 6 lần với 6 cách chia dữ liệu: F1 hai bên chênh khoảng 0,0001. Hai, đo sai số của F1: chỉ khoảng cộng trừ 0,0001, rất nhỏ. Ba, kiểm tra hai bên có khác nhau không: có, nhưng chỉ 0,0001. Bốn, kiểm tra hai bên có coi như nhau được không, với mức chênh cho phép cộng trừ 0,001 đặt trước: được. Hình nhỏ: vùng xanh lá là mức cho phép, đoạn xanh dương là chênh lệch thật, nằm gọn trong đó. Vì vậy chọn SHAP Top-30: ít đặc trưng hơn mà tốt ngang, lại giải thích được.</a:t>
             </a:r>
           </a:p>
-          <a:p/>
+          <a:p>
+            <a:endParaRPr/>
+          </a:p>
           <a:p>
             <a:r>
               <a:t>Nếu bị hỏi: Phép 1: các lần chạy dùng chung dữ liệu nên khoảng tin cậy thông thường hẹp quá, Nadeau–Bengio hiệu chỉnh việc đó. Phép 2: kiểm định hoán vị hai phía liệt kê đủ 26 tổ hợp dấu, nên p nhỏ nhất là 2/26 = 0,031, cần N ≥ 6. Cohen’s d ≈ 1,94 lớn vì phương sai giữa các lần chạy rất nhỏ, không phải vì chênh lệch lớn. Phép 3: p của phép 2 không chứng minh được hai bên giống nhau, nên dùng TOST với biên ±0,001 F1 trên sai số Nadeau–Bengio; biên nhỏ nhất chứng minh được ở α = 0,05 là ±2,3 × 10−4. Xem slide dự phòng.</a:t>
@@ -1500,7 +1314,7 @@
             <a:spLocks noGrp="1"/>
           </p:cNvSpPr>
           <p:nvPr>
-            <p:ph type="sldNum" idx="5" sz="quarter"/>
+            <p:ph type="sldNum" sz="quarter" idx="5"/>
           </p:nvPr>
         </p:nvSpPr>
         <p:spPr/>
@@ -1551,10 +1365,9 @@
           <a:lstStyle/>
           <a:p>
             <a:r>
-              <a:rPr lang="en-US" smtClean="0"/>
+              <a:rPr lang="en-US"/>
               <a:t>Click to edit Master title style</a:t>
             </a:r>
-            <a:endParaRPr lang="en-US"/>
           </a:p>
         </p:txBody>
       </p:sp>
@@ -1670,10 +1483,9 @@
           </a:lstStyle>
           <a:p>
             <a:r>
-              <a:rPr lang="en-US" smtClean="0"/>
+              <a:rPr lang="en-US"/>
               <a:t>Click to edit Master subtitle style</a:t>
             </a:r>
-            <a:endParaRPr lang="en-US"/>
           </a:p>
         </p:txBody>
       </p:sp>
@@ -1694,7 +1506,7 @@
           <a:p>
             <a:fld id="{5BCAD085-E8A6-8845-BD4E-CB4CCA059FC4}" type="datetimeFigureOut">
               <a:rPr lang="en-US" smtClean="0"/>
-              <a:t>1/27/13</a:t>
+              <a:t>10/8/26</a:t>
             </a:fld>
             <a:endParaRPr lang="en-US"/>
           </a:p>
@@ -1788,10 +1600,9 @@
           <a:lstStyle/>
           <a:p>
             <a:r>
-              <a:rPr lang="en-US" smtClean="0"/>
+              <a:rPr lang="en-US"/>
               <a:t>Click to edit Master title style</a:t>
             </a:r>
-            <a:endParaRPr lang="en-US"/>
           </a:p>
         </p:txBody>
       </p:sp>
@@ -1812,38 +1623,37 @@
           <a:p>
             <a:pPr lvl="0"/>
             <a:r>
-              <a:rPr lang="en-US" smtClean="0"/>
+              <a:rPr lang="en-US"/>
               <a:t>Click to edit Master text styles</a:t>
             </a:r>
           </a:p>
           <a:p>
             <a:pPr lvl="1"/>
             <a:r>
-              <a:rPr lang="en-US" smtClean="0"/>
+              <a:rPr lang="en-US"/>
               <a:t>Second level</a:t>
             </a:r>
           </a:p>
           <a:p>
             <a:pPr lvl="2"/>
             <a:r>
-              <a:rPr lang="en-US" smtClean="0"/>
+              <a:rPr lang="en-US"/>
               <a:t>Third level</a:t>
             </a:r>
           </a:p>
           <a:p>
             <a:pPr lvl="3"/>
             <a:r>
-              <a:rPr lang="en-US" smtClean="0"/>
+              <a:rPr lang="en-US"/>
               <a:t>Fourth level</a:t>
             </a:r>
           </a:p>
           <a:p>
             <a:pPr lvl="4"/>
             <a:r>
-              <a:rPr lang="en-US" smtClean="0"/>
+              <a:rPr lang="en-US"/>
               <a:t>Fifth level</a:t>
             </a:r>
-            <a:endParaRPr lang="en-US"/>
           </a:p>
         </p:txBody>
       </p:sp>
@@ -1864,7 +1674,7 @@
           <a:p>
             <a:fld id="{5BCAD085-E8A6-8845-BD4E-CB4CCA059FC4}" type="datetimeFigureOut">
               <a:rPr lang="en-US" smtClean="0"/>
-              <a:t>1/27/13</a:t>
+              <a:t>10/8/26</a:t>
             </a:fld>
             <a:endParaRPr lang="en-US"/>
           </a:p>
@@ -1963,10 +1773,9 @@
           <a:lstStyle/>
           <a:p>
             <a:r>
-              <a:rPr lang="en-US" smtClean="0"/>
+              <a:rPr lang="en-US"/>
               <a:t>Click to edit Master title style</a:t>
             </a:r>
-            <a:endParaRPr lang="en-US"/>
           </a:p>
         </p:txBody>
       </p:sp>
@@ -1992,38 +1801,37 @@
           <a:p>
             <a:pPr lvl="0"/>
             <a:r>
-              <a:rPr lang="en-US" smtClean="0"/>
+              <a:rPr lang="en-US"/>
               <a:t>Click to edit Master text styles</a:t>
             </a:r>
           </a:p>
           <a:p>
             <a:pPr lvl="1"/>
             <a:r>
-              <a:rPr lang="en-US" smtClean="0"/>
+              <a:rPr lang="en-US"/>
               <a:t>Second level</a:t>
             </a:r>
           </a:p>
           <a:p>
             <a:pPr lvl="2"/>
             <a:r>
-              <a:rPr lang="en-US" smtClean="0"/>
+              <a:rPr lang="en-US"/>
               <a:t>Third level</a:t>
             </a:r>
           </a:p>
           <a:p>
             <a:pPr lvl="3"/>
             <a:r>
-              <a:rPr lang="en-US" smtClean="0"/>
+              <a:rPr lang="en-US"/>
               <a:t>Fourth level</a:t>
             </a:r>
           </a:p>
           <a:p>
             <a:pPr lvl="4"/>
             <a:r>
-              <a:rPr lang="en-US" smtClean="0"/>
+              <a:rPr lang="en-US"/>
               <a:t>Fifth level</a:t>
             </a:r>
-            <a:endParaRPr lang="en-US"/>
           </a:p>
         </p:txBody>
       </p:sp>
@@ -2044,7 +1852,7 @@
           <a:p>
             <a:fld id="{5BCAD085-E8A6-8845-BD4E-CB4CCA059FC4}" type="datetimeFigureOut">
               <a:rPr lang="en-US" smtClean="0"/>
-              <a:t>1/27/13</a:t>
+              <a:t>10/8/26</a:t>
             </a:fld>
             <a:endParaRPr lang="en-US"/>
           </a:p>
@@ -2138,10 +1946,9 @@
           <a:lstStyle/>
           <a:p>
             <a:r>
-              <a:rPr lang="en-US" smtClean="0"/>
+              <a:rPr lang="en-US"/>
               <a:t>Click to edit Master title style</a:t>
             </a:r>
-            <a:endParaRPr lang="en-US"/>
           </a:p>
         </p:txBody>
       </p:sp>
@@ -2162,38 +1969,37 @@
           <a:p>
             <a:pPr lvl="0"/>
             <a:r>
-              <a:rPr lang="en-US" smtClean="0"/>
+              <a:rPr lang="en-US"/>
               <a:t>Click to edit Master text styles</a:t>
             </a:r>
           </a:p>
           <a:p>
             <a:pPr lvl="1"/>
             <a:r>
-              <a:rPr lang="en-US" smtClean="0"/>
+              <a:rPr lang="en-US"/>
               <a:t>Second level</a:t>
             </a:r>
           </a:p>
           <a:p>
             <a:pPr lvl="2"/>
             <a:r>
-              <a:rPr lang="en-US" smtClean="0"/>
+              <a:rPr lang="en-US"/>
               <a:t>Third level</a:t>
             </a:r>
           </a:p>
           <a:p>
             <a:pPr lvl="3"/>
             <a:r>
-              <a:rPr lang="en-US" smtClean="0"/>
+              <a:rPr lang="en-US"/>
               <a:t>Fourth level</a:t>
             </a:r>
           </a:p>
           <a:p>
             <a:pPr lvl="4"/>
             <a:r>
-              <a:rPr lang="en-US" smtClean="0"/>
+              <a:rPr lang="en-US"/>
               <a:t>Fifth level</a:t>
             </a:r>
-            <a:endParaRPr lang="en-US"/>
           </a:p>
         </p:txBody>
       </p:sp>
@@ -2214,7 +2020,7 @@
           <a:p>
             <a:fld id="{5BCAD085-E8A6-8845-BD4E-CB4CCA059FC4}" type="datetimeFigureOut">
               <a:rPr lang="en-US" smtClean="0"/>
-              <a:t>1/27/13</a:t>
+              <a:t>10/8/26</a:t>
             </a:fld>
             <a:endParaRPr lang="en-US"/>
           </a:p>
@@ -2317,10 +2123,9 @@
           </a:lstStyle>
           <a:p>
             <a:r>
-              <a:rPr lang="en-US" smtClean="0"/>
+              <a:rPr lang="en-US"/>
               <a:t>Click to edit Master title style</a:t>
             </a:r>
-            <a:endParaRPr lang="en-US"/>
           </a:p>
         </p:txBody>
       </p:sp>
@@ -2437,7 +2242,7 @@
           <a:p>
             <a:pPr lvl="0"/>
             <a:r>
-              <a:rPr lang="en-US" smtClean="0"/>
+              <a:rPr lang="en-US"/>
               <a:t>Click to edit Master text styles</a:t>
             </a:r>
           </a:p>
@@ -2460,7 +2265,7 @@
           <a:p>
             <a:fld id="{5BCAD085-E8A6-8845-BD4E-CB4CCA059FC4}" type="datetimeFigureOut">
               <a:rPr lang="en-US" smtClean="0"/>
-              <a:t>1/27/13</a:t>
+              <a:t>10/8/26</a:t>
             </a:fld>
             <a:endParaRPr lang="en-US"/>
           </a:p>
@@ -2554,10 +2359,9 @@
           <a:lstStyle/>
           <a:p>
             <a:r>
-              <a:rPr lang="en-US" smtClean="0"/>
+              <a:rPr lang="en-US"/>
               <a:t>Click to edit Master title style</a:t>
             </a:r>
-            <a:endParaRPr lang="en-US"/>
           </a:p>
         </p:txBody>
       </p:sp>
@@ -2611,38 +2415,37 @@
           <a:p>
             <a:pPr lvl="0"/>
             <a:r>
-              <a:rPr lang="en-US" smtClean="0"/>
+              <a:rPr lang="en-US"/>
               <a:t>Click to edit Master text styles</a:t>
             </a:r>
           </a:p>
           <a:p>
             <a:pPr lvl="1"/>
             <a:r>
-              <a:rPr lang="en-US" smtClean="0"/>
+              <a:rPr lang="en-US"/>
               <a:t>Second level</a:t>
             </a:r>
           </a:p>
           <a:p>
             <a:pPr lvl="2"/>
             <a:r>
-              <a:rPr lang="en-US" smtClean="0"/>
+              <a:rPr lang="en-US"/>
               <a:t>Third level</a:t>
             </a:r>
           </a:p>
           <a:p>
             <a:pPr lvl="3"/>
             <a:r>
-              <a:rPr lang="en-US" smtClean="0"/>
+              <a:rPr lang="en-US"/>
               <a:t>Fourth level</a:t>
             </a:r>
           </a:p>
           <a:p>
             <a:pPr lvl="4"/>
             <a:r>
-              <a:rPr lang="en-US" smtClean="0"/>
+              <a:rPr lang="en-US"/>
               <a:t>Fifth level</a:t>
             </a:r>
-            <a:endParaRPr lang="en-US"/>
           </a:p>
         </p:txBody>
       </p:sp>
@@ -2696,38 +2499,37 @@
           <a:p>
             <a:pPr lvl="0"/>
             <a:r>
-              <a:rPr lang="en-US" smtClean="0"/>
+              <a:rPr lang="en-US"/>
               <a:t>Click to edit Master text styles</a:t>
             </a:r>
           </a:p>
           <a:p>
             <a:pPr lvl="1"/>
             <a:r>
-              <a:rPr lang="en-US" smtClean="0"/>
+              <a:rPr lang="en-US"/>
               <a:t>Second level</a:t>
             </a:r>
           </a:p>
           <a:p>
             <a:pPr lvl="2"/>
             <a:r>
-              <a:rPr lang="en-US" smtClean="0"/>
+              <a:rPr lang="en-US"/>
               <a:t>Third level</a:t>
             </a:r>
           </a:p>
           <a:p>
             <a:pPr lvl="3"/>
             <a:r>
-              <a:rPr lang="en-US" smtClean="0"/>
+              <a:rPr lang="en-US"/>
               <a:t>Fourth level</a:t>
             </a:r>
           </a:p>
           <a:p>
             <a:pPr lvl="4"/>
             <a:r>
-              <a:rPr lang="en-US" smtClean="0"/>
+              <a:rPr lang="en-US"/>
               <a:t>Fifth level</a:t>
             </a:r>
-            <a:endParaRPr lang="en-US"/>
           </a:p>
         </p:txBody>
       </p:sp>
@@ -2748,7 +2550,7 @@
           <a:p>
             <a:fld id="{5BCAD085-E8A6-8845-BD4E-CB4CCA059FC4}" type="datetimeFigureOut">
               <a:rPr lang="en-US" smtClean="0"/>
-              <a:t>1/27/13</a:t>
+              <a:t>10/8/26</a:t>
             </a:fld>
             <a:endParaRPr lang="en-US"/>
           </a:p>
@@ -2846,10 +2648,9 @@
           </a:lstStyle>
           <a:p>
             <a:r>
-              <a:rPr lang="en-US" smtClean="0"/>
+              <a:rPr lang="en-US"/>
               <a:t>Click to edit Master title style</a:t>
             </a:r>
-            <a:endParaRPr lang="en-US"/>
           </a:p>
         </p:txBody>
       </p:sp>
@@ -2912,7 +2713,7 @@
           <a:p>
             <a:pPr lvl="0"/>
             <a:r>
-              <a:rPr lang="en-US" smtClean="0"/>
+              <a:rPr lang="en-US"/>
               <a:t>Click to edit Master text styles</a:t>
             </a:r>
           </a:p>
@@ -2968,38 +2769,37 @@
           <a:p>
             <a:pPr lvl="0"/>
             <a:r>
-              <a:rPr lang="en-US" smtClean="0"/>
+              <a:rPr lang="en-US"/>
               <a:t>Click to edit Master text styles</a:t>
             </a:r>
           </a:p>
           <a:p>
             <a:pPr lvl="1"/>
             <a:r>
-              <a:rPr lang="en-US" smtClean="0"/>
+              <a:rPr lang="en-US"/>
               <a:t>Second level</a:t>
             </a:r>
           </a:p>
           <a:p>
             <a:pPr lvl="2"/>
             <a:r>
-              <a:rPr lang="en-US" smtClean="0"/>
+              <a:rPr lang="en-US"/>
               <a:t>Third level</a:t>
             </a:r>
           </a:p>
           <a:p>
             <a:pPr lvl="3"/>
             <a:r>
-              <a:rPr lang="en-US" smtClean="0"/>
+              <a:rPr lang="en-US"/>
               <a:t>Fourth level</a:t>
             </a:r>
           </a:p>
           <a:p>
             <a:pPr lvl="4"/>
             <a:r>
-              <a:rPr lang="en-US" smtClean="0"/>
+              <a:rPr lang="en-US"/>
               <a:t>Fifth level</a:t>
             </a:r>
-            <a:endParaRPr lang="en-US"/>
           </a:p>
         </p:txBody>
       </p:sp>
@@ -3062,7 +2862,7 @@
           <a:p>
             <a:pPr lvl="0"/>
             <a:r>
-              <a:rPr lang="en-US" smtClean="0"/>
+              <a:rPr lang="en-US"/>
               <a:t>Click to edit Master text styles</a:t>
             </a:r>
           </a:p>
@@ -3118,38 +2918,37 @@
           <a:p>
             <a:pPr lvl="0"/>
             <a:r>
-              <a:rPr lang="en-US" smtClean="0"/>
+              <a:rPr lang="en-US"/>
               <a:t>Click to edit Master text styles</a:t>
             </a:r>
           </a:p>
           <a:p>
             <a:pPr lvl="1"/>
             <a:r>
-              <a:rPr lang="en-US" smtClean="0"/>
+              <a:rPr lang="en-US"/>
               <a:t>Second level</a:t>
             </a:r>
           </a:p>
           <a:p>
             <a:pPr lvl="2"/>
             <a:r>
-              <a:rPr lang="en-US" smtClean="0"/>
+              <a:rPr lang="en-US"/>
               <a:t>Third level</a:t>
             </a:r>
           </a:p>
           <a:p>
             <a:pPr lvl="3"/>
             <a:r>
-              <a:rPr lang="en-US" smtClean="0"/>
+              <a:rPr lang="en-US"/>
               <a:t>Fourth level</a:t>
             </a:r>
           </a:p>
           <a:p>
             <a:pPr lvl="4"/>
             <a:r>
-              <a:rPr lang="en-US" smtClean="0"/>
+              <a:rPr lang="en-US"/>
               <a:t>Fifth level</a:t>
             </a:r>
-            <a:endParaRPr lang="en-US"/>
           </a:p>
         </p:txBody>
       </p:sp>
@@ -3170,7 +2969,7 @@
           <a:p>
             <a:fld id="{5BCAD085-E8A6-8845-BD4E-CB4CCA059FC4}" type="datetimeFigureOut">
               <a:rPr lang="en-US" smtClean="0"/>
-              <a:t>1/27/13</a:t>
+              <a:t>10/8/26</a:t>
             </a:fld>
             <a:endParaRPr lang="en-US"/>
           </a:p>
@@ -3264,10 +3063,9 @@
           <a:lstStyle/>
           <a:p>
             <a:r>
-              <a:rPr lang="en-US" smtClean="0"/>
+              <a:rPr lang="en-US"/>
               <a:t>Click to edit Master title style</a:t>
             </a:r>
-            <a:endParaRPr lang="en-US"/>
           </a:p>
         </p:txBody>
       </p:sp>
@@ -3288,7 +3086,7 @@
           <a:p>
             <a:fld id="{5BCAD085-E8A6-8845-BD4E-CB4CCA059FC4}" type="datetimeFigureOut">
               <a:rPr lang="en-US" smtClean="0"/>
-              <a:t>1/27/13</a:t>
+              <a:t>10/8/26</a:t>
             </a:fld>
             <a:endParaRPr lang="en-US"/>
           </a:p>
@@ -3383,7 +3181,7 @@
           <a:p>
             <a:fld id="{5BCAD085-E8A6-8845-BD4E-CB4CCA059FC4}" type="datetimeFigureOut">
               <a:rPr lang="en-US" smtClean="0"/>
-              <a:t>1/27/13</a:t>
+              <a:t>10/8/26</a:t>
             </a:fld>
             <a:endParaRPr lang="en-US"/>
           </a:p>
@@ -3486,10 +3284,9 @@
           </a:lstStyle>
           <a:p>
             <a:r>
-              <a:rPr lang="en-US" smtClean="0"/>
+              <a:rPr lang="en-US"/>
               <a:t>Click to edit Master title style</a:t>
             </a:r>
-            <a:endParaRPr lang="en-US"/>
           </a:p>
         </p:txBody>
       </p:sp>
@@ -3543,38 +3340,37 @@
           <a:p>
             <a:pPr lvl="0"/>
             <a:r>
-              <a:rPr lang="en-US" smtClean="0"/>
+              <a:rPr lang="en-US"/>
               <a:t>Click to edit Master text styles</a:t>
             </a:r>
           </a:p>
           <a:p>
             <a:pPr lvl="1"/>
             <a:r>
-              <a:rPr lang="en-US" smtClean="0"/>
+              <a:rPr lang="en-US"/>
               <a:t>Second level</a:t>
             </a:r>
           </a:p>
           <a:p>
             <a:pPr lvl="2"/>
             <a:r>
-              <a:rPr lang="en-US" smtClean="0"/>
+              <a:rPr lang="en-US"/>
               <a:t>Third level</a:t>
             </a:r>
           </a:p>
           <a:p>
             <a:pPr lvl="3"/>
             <a:r>
-              <a:rPr lang="en-US" smtClean="0"/>
+              <a:rPr lang="en-US"/>
               <a:t>Fourth level</a:t>
             </a:r>
           </a:p>
           <a:p>
             <a:pPr lvl="4"/>
             <a:r>
-              <a:rPr lang="en-US" smtClean="0"/>
+              <a:rPr lang="en-US"/>
               <a:t>Fifth level</a:t>
             </a:r>
-            <a:endParaRPr lang="en-US"/>
           </a:p>
         </p:txBody>
       </p:sp>
@@ -3637,7 +3433,7 @@
           <a:p>
             <a:pPr lvl="0"/>
             <a:r>
-              <a:rPr lang="en-US" smtClean="0"/>
+              <a:rPr lang="en-US"/>
               <a:t>Click to edit Master text styles</a:t>
             </a:r>
           </a:p>
@@ -3660,7 +3456,7 @@
           <a:p>
             <a:fld id="{5BCAD085-E8A6-8845-BD4E-CB4CCA059FC4}" type="datetimeFigureOut">
               <a:rPr lang="en-US" smtClean="0"/>
-              <a:t>1/27/13</a:t>
+              <a:t>10/8/26</a:t>
             </a:fld>
             <a:endParaRPr lang="en-US"/>
           </a:p>
@@ -3763,10 +3559,9 @@
           </a:lstStyle>
           <a:p>
             <a:r>
-              <a:rPr lang="en-US" smtClean="0"/>
+              <a:rPr lang="en-US"/>
               <a:t>Click to edit Master title style</a:t>
             </a:r>
-            <a:endParaRPr lang="en-US"/>
           </a:p>
         </p:txBody>
       </p:sp>
@@ -3890,7 +3685,7 @@
           <a:p>
             <a:pPr lvl="0"/>
             <a:r>
-              <a:rPr lang="en-US" smtClean="0"/>
+              <a:rPr lang="en-US"/>
               <a:t>Click to edit Master text styles</a:t>
             </a:r>
           </a:p>
@@ -3913,7 +3708,7 @@
           <a:p>
             <a:fld id="{5BCAD085-E8A6-8845-BD4E-CB4CCA059FC4}" type="datetimeFigureOut">
               <a:rPr lang="en-US" smtClean="0"/>
-              <a:t>1/27/13</a:t>
+              <a:t>10/8/26</a:t>
             </a:fld>
             <a:endParaRPr lang="en-US"/>
           </a:p>
@@ -4022,10 +3817,9 @@
           <a:lstStyle/>
           <a:p>
             <a:r>
-              <a:rPr lang="en-US" smtClean="0"/>
+              <a:rPr lang="en-US"/>
               <a:t>Click to edit Master title style</a:t>
             </a:r>
-            <a:endParaRPr lang="en-US"/>
           </a:p>
         </p:txBody>
       </p:sp>
@@ -4056,38 +3850,37 @@
           <a:p>
             <a:pPr lvl="0"/>
             <a:r>
-              <a:rPr lang="en-US" smtClean="0"/>
+              <a:rPr lang="en-US"/>
               <a:t>Click to edit Master text styles</a:t>
             </a:r>
           </a:p>
           <a:p>
             <a:pPr lvl="1"/>
             <a:r>
-              <a:rPr lang="en-US" smtClean="0"/>
+              <a:rPr lang="en-US"/>
               <a:t>Second level</a:t>
             </a:r>
           </a:p>
           <a:p>
             <a:pPr lvl="2"/>
             <a:r>
-              <a:rPr lang="en-US" smtClean="0"/>
+              <a:rPr lang="en-US"/>
               <a:t>Third level</a:t>
             </a:r>
           </a:p>
           <a:p>
             <a:pPr lvl="3"/>
             <a:r>
-              <a:rPr lang="en-US" smtClean="0"/>
+              <a:rPr lang="en-US"/>
               <a:t>Fourth level</a:t>
             </a:r>
           </a:p>
           <a:p>
             <a:pPr lvl="4"/>
             <a:r>
-              <a:rPr lang="en-US" smtClean="0"/>
+              <a:rPr lang="en-US"/>
               <a:t>Fifth level</a:t>
             </a:r>
-            <a:endParaRPr lang="en-US"/>
           </a:p>
         </p:txBody>
       </p:sp>
@@ -4126,7 +3919,7 @@
           <a:p>
             <a:fld id="{5BCAD085-E8A6-8845-BD4E-CB4CCA059FC4}" type="datetimeFigureOut">
               <a:rPr lang="en-US" smtClean="0"/>
-              <a:t>1/27/13</a:t>
+              <a:t>10/8/26</a:t>
             </a:fld>
             <a:endParaRPr lang="en-US"/>
           </a:p>
@@ -4485,7 +4278,7 @@
 </file>
 
 <file path=ppt/slides/slide1.xml><?xml version="1.0" encoding="utf-8"?>
-<p:sld xmlns:a="http://schemas.openxmlformats.org/drawingml/2006/main" xmlns:p="http://schemas.openxmlformats.org/presentationml/2006/main" xmlns:r="http://schemas.openxmlformats.org/officeDocument/2006/relationships">
+<p:sld xmlns:a="http://schemas.openxmlformats.org/drawingml/2006/main" xmlns:r="http://schemas.openxmlformats.org/officeDocument/2006/relationships" xmlns:p="http://schemas.openxmlformats.org/presentationml/2006/main">
   <p:cSld>
     <p:spTree>
       <p:nvGrpSpPr>
@@ -4493,7 +4286,14 @@
         <p:cNvGrpSpPr/>
         <p:nvPr/>
       </p:nvGrpSpPr>
-      <p:grpSpPr/>
+      <p:grpSpPr>
+        <a:xfrm>
+          <a:off x="0" y="0"/>
+          <a:ext cx="0" cy="0"/>
+          <a:chOff x="0" y="0"/>
+          <a:chExt cx="0" cy="0"/>
+        </a:xfrm>
+      </p:grpSpPr>
       <p:pic>
         <p:nvPicPr>
           <p:cNvPr id="2" name="Picture 1" descr="p-01.png"/>
@@ -4503,7 +4303,7 @@
           <p:nvPr/>
         </p:nvPicPr>
         <p:blipFill>
-          <a:blip r:embed="rId2"/>
+          <a:blip r:embed="rId3"/>
           <a:stretch>
             <a:fillRect/>
           </a:stretch>
@@ -4527,7 +4327,7 @@
 </file>
 
 <file path=ppt/slides/slide10.xml><?xml version="1.0" encoding="utf-8"?>
-<p:sld xmlns:a="http://schemas.openxmlformats.org/drawingml/2006/main" xmlns:p="http://schemas.openxmlformats.org/presentationml/2006/main" xmlns:r="http://schemas.openxmlformats.org/officeDocument/2006/relationships">
+<p:sld xmlns:a="http://schemas.openxmlformats.org/drawingml/2006/main" xmlns:r="http://schemas.openxmlformats.org/officeDocument/2006/relationships" xmlns:p="http://schemas.openxmlformats.org/presentationml/2006/main">
   <p:cSld>
     <p:spTree>
       <p:nvGrpSpPr>
@@ -4535,7 +4335,14 @@
         <p:cNvGrpSpPr/>
         <p:nvPr/>
       </p:nvGrpSpPr>
-      <p:grpSpPr/>
+      <p:grpSpPr>
+        <a:xfrm>
+          <a:off x="0" y="0"/>
+          <a:ext cx="0" cy="0"/>
+          <a:chOff x="0" y="0"/>
+          <a:chExt cx="0" cy="0"/>
+        </a:xfrm>
+      </p:grpSpPr>
       <p:pic>
         <p:nvPicPr>
           <p:cNvPr id="2" name="Picture 1" descr="p-10.png"/>
@@ -4545,7 +4352,7 @@
           <p:nvPr/>
         </p:nvPicPr>
         <p:blipFill>
-          <a:blip r:embed="rId2"/>
+          <a:blip r:embed="rId3"/>
           <a:stretch>
             <a:fillRect/>
           </a:stretch>
@@ -4569,7 +4376,7 @@
 </file>
 
 <file path=ppt/slides/slide11.xml><?xml version="1.0" encoding="utf-8"?>
-<p:sld xmlns:a="http://schemas.openxmlformats.org/drawingml/2006/main" xmlns:p="http://schemas.openxmlformats.org/presentationml/2006/main" xmlns:r="http://schemas.openxmlformats.org/officeDocument/2006/relationships">
+<p:sld xmlns:a="http://schemas.openxmlformats.org/drawingml/2006/main" xmlns:r="http://schemas.openxmlformats.org/officeDocument/2006/relationships" xmlns:p="http://schemas.openxmlformats.org/presentationml/2006/main">
   <p:cSld>
     <p:spTree>
       <p:nvGrpSpPr>
@@ -4577,7 +4384,14 @@
         <p:cNvGrpSpPr/>
         <p:nvPr/>
       </p:nvGrpSpPr>
-      <p:grpSpPr/>
+      <p:grpSpPr>
+        <a:xfrm>
+          <a:off x="0" y="0"/>
+          <a:ext cx="0" cy="0"/>
+          <a:chOff x="0" y="0"/>
+          <a:chExt cx="0" cy="0"/>
+        </a:xfrm>
+      </p:grpSpPr>
       <p:pic>
         <p:nvPicPr>
           <p:cNvPr id="2" name="Picture 1" descr="p-11.png"/>
@@ -4587,7 +4401,7 @@
           <p:nvPr/>
         </p:nvPicPr>
         <p:blipFill>
-          <a:blip r:embed="rId2"/>
+          <a:blip r:embed="rId3"/>
           <a:stretch>
             <a:fillRect/>
           </a:stretch>
@@ -4611,7 +4425,7 @@
 </file>
 
 <file path=ppt/slides/slide12.xml><?xml version="1.0" encoding="utf-8"?>
-<p:sld xmlns:a="http://schemas.openxmlformats.org/drawingml/2006/main" xmlns:p="http://schemas.openxmlformats.org/presentationml/2006/main" xmlns:r="http://schemas.openxmlformats.org/officeDocument/2006/relationships">
+<p:sld xmlns:a="http://schemas.openxmlformats.org/drawingml/2006/main" xmlns:r="http://schemas.openxmlformats.org/officeDocument/2006/relationships" xmlns:p="http://schemas.openxmlformats.org/presentationml/2006/main">
   <p:cSld>
     <p:spTree>
       <p:nvGrpSpPr>
@@ -4619,7 +4433,14 @@
         <p:cNvGrpSpPr/>
         <p:nvPr/>
       </p:nvGrpSpPr>
-      <p:grpSpPr/>
+      <p:grpSpPr>
+        <a:xfrm>
+          <a:off x="0" y="0"/>
+          <a:ext cx="0" cy="0"/>
+          <a:chOff x="0" y="0"/>
+          <a:chExt cx="0" cy="0"/>
+        </a:xfrm>
+      </p:grpSpPr>
       <p:pic>
         <p:nvPicPr>
           <p:cNvPr id="2" name="Picture 1" descr="p-12.png"/>
@@ -4629,7 +4450,7 @@
           <p:nvPr/>
         </p:nvPicPr>
         <p:blipFill>
-          <a:blip r:embed="rId2"/>
+          <a:blip r:embed="rId3"/>
           <a:stretch>
             <a:fillRect/>
           </a:stretch>
@@ -4653,7 +4474,7 @@
 </file>
 
 <file path=ppt/slides/slide13.xml><?xml version="1.0" encoding="utf-8"?>
-<p:sld xmlns:a="http://schemas.openxmlformats.org/drawingml/2006/main" xmlns:p="http://schemas.openxmlformats.org/presentationml/2006/main" xmlns:r="http://schemas.openxmlformats.org/officeDocument/2006/relationships">
+<p:sld xmlns:a="http://schemas.openxmlformats.org/drawingml/2006/main" xmlns:r="http://schemas.openxmlformats.org/officeDocument/2006/relationships" xmlns:p="http://schemas.openxmlformats.org/presentationml/2006/main">
   <p:cSld>
     <p:spTree>
       <p:nvGrpSpPr>
@@ -4661,7 +4482,14 @@
         <p:cNvGrpSpPr/>
         <p:nvPr/>
       </p:nvGrpSpPr>
-      <p:grpSpPr/>
+      <p:grpSpPr>
+        <a:xfrm>
+          <a:off x="0" y="0"/>
+          <a:ext cx="0" cy="0"/>
+          <a:chOff x="0" y="0"/>
+          <a:chExt cx="0" cy="0"/>
+        </a:xfrm>
+      </p:grpSpPr>
       <p:pic>
         <p:nvPicPr>
           <p:cNvPr id="2" name="Picture 1" descr="p-13.png"/>
@@ -4671,7 +4499,7 @@
           <p:nvPr/>
         </p:nvPicPr>
         <p:blipFill>
-          <a:blip r:embed="rId2"/>
+          <a:blip r:embed="rId3"/>
           <a:stretch>
             <a:fillRect/>
           </a:stretch>
@@ -4695,7 +4523,7 @@
 </file>
 
 <file path=ppt/slides/slide14.xml><?xml version="1.0" encoding="utf-8"?>
-<p:sld xmlns:a="http://schemas.openxmlformats.org/drawingml/2006/main" xmlns:p="http://schemas.openxmlformats.org/presentationml/2006/main" xmlns:r="http://schemas.openxmlformats.org/officeDocument/2006/relationships">
+<p:sld xmlns:a="http://schemas.openxmlformats.org/drawingml/2006/main" xmlns:r="http://schemas.openxmlformats.org/officeDocument/2006/relationships" xmlns:p="http://schemas.openxmlformats.org/presentationml/2006/main">
   <p:cSld>
     <p:spTree>
       <p:nvGrpSpPr>
@@ -4703,7 +4531,14 @@
         <p:cNvGrpSpPr/>
         <p:nvPr/>
       </p:nvGrpSpPr>
-      <p:grpSpPr/>
+      <p:grpSpPr>
+        <a:xfrm>
+          <a:off x="0" y="0"/>
+          <a:ext cx="0" cy="0"/>
+          <a:chOff x="0" y="0"/>
+          <a:chExt cx="0" cy="0"/>
+        </a:xfrm>
+      </p:grpSpPr>
       <p:pic>
         <p:nvPicPr>
           <p:cNvPr id="2" name="Picture 1" descr="p-14.png"/>
@@ -4713,7 +4548,7 @@
           <p:nvPr/>
         </p:nvPicPr>
         <p:blipFill>
-          <a:blip r:embed="rId2"/>
+          <a:blip r:embed="rId3"/>
           <a:stretch>
             <a:fillRect/>
           </a:stretch>
@@ -4737,7 +4572,7 @@
 </file>
 
 <file path=ppt/slides/slide15.xml><?xml version="1.0" encoding="utf-8"?>
-<p:sld xmlns:a="http://schemas.openxmlformats.org/drawingml/2006/main" xmlns:p="http://schemas.openxmlformats.org/presentationml/2006/main" xmlns:r="http://schemas.openxmlformats.org/officeDocument/2006/relationships">
+<p:sld xmlns:a="http://schemas.openxmlformats.org/drawingml/2006/main" xmlns:r="http://schemas.openxmlformats.org/officeDocument/2006/relationships" xmlns:p="http://schemas.openxmlformats.org/presentationml/2006/main">
   <p:cSld>
     <p:spTree>
       <p:nvGrpSpPr>
@@ -4745,7 +4580,14 @@
         <p:cNvGrpSpPr/>
         <p:nvPr/>
       </p:nvGrpSpPr>
-      <p:grpSpPr/>
+      <p:grpSpPr>
+        <a:xfrm>
+          <a:off x="0" y="0"/>
+          <a:ext cx="0" cy="0"/>
+          <a:chOff x="0" y="0"/>
+          <a:chExt cx="0" cy="0"/>
+        </a:xfrm>
+      </p:grpSpPr>
       <p:pic>
         <p:nvPicPr>
           <p:cNvPr id="2" name="Picture 1" descr="p-15.png"/>
@@ -4755,7 +4597,7 @@
           <p:nvPr/>
         </p:nvPicPr>
         <p:blipFill>
-          <a:blip r:embed="rId2"/>
+          <a:blip r:embed="rId3"/>
           <a:stretch>
             <a:fillRect/>
           </a:stretch>
@@ -4779,7 +4621,7 @@
 </file>
 
 <file path=ppt/slides/slide16.xml><?xml version="1.0" encoding="utf-8"?>
-<p:sld xmlns:a="http://schemas.openxmlformats.org/drawingml/2006/main" xmlns:p="http://schemas.openxmlformats.org/presentationml/2006/main" xmlns:r="http://schemas.openxmlformats.org/officeDocument/2006/relationships">
+<p:sld xmlns:a="http://schemas.openxmlformats.org/drawingml/2006/main" xmlns:r="http://schemas.openxmlformats.org/officeDocument/2006/relationships" xmlns:p="http://schemas.openxmlformats.org/presentationml/2006/main">
   <p:cSld>
     <p:spTree>
       <p:nvGrpSpPr>
@@ -4787,7 +4629,14 @@
         <p:cNvGrpSpPr/>
         <p:nvPr/>
       </p:nvGrpSpPr>
-      <p:grpSpPr/>
+      <p:grpSpPr>
+        <a:xfrm>
+          <a:off x="0" y="0"/>
+          <a:ext cx="0" cy="0"/>
+          <a:chOff x="0" y="0"/>
+          <a:chExt cx="0" cy="0"/>
+        </a:xfrm>
+      </p:grpSpPr>
       <p:pic>
         <p:nvPicPr>
           <p:cNvPr id="2" name="Picture 1" descr="p-16.png"/>
@@ -4797,7 +4646,7 @@
           <p:nvPr/>
         </p:nvPicPr>
         <p:blipFill>
-          <a:blip r:embed="rId2"/>
+          <a:blip r:embed="rId3"/>
           <a:stretch>
             <a:fillRect/>
           </a:stretch>
@@ -4821,7 +4670,7 @@
 </file>
 
 <file path=ppt/slides/slide17.xml><?xml version="1.0" encoding="utf-8"?>
-<p:sld xmlns:a="http://schemas.openxmlformats.org/drawingml/2006/main" xmlns:p="http://schemas.openxmlformats.org/presentationml/2006/main" xmlns:r="http://schemas.openxmlformats.org/officeDocument/2006/relationships">
+<p:sld xmlns:a="http://schemas.openxmlformats.org/drawingml/2006/main" xmlns:r="http://schemas.openxmlformats.org/officeDocument/2006/relationships" xmlns:p="http://schemas.openxmlformats.org/presentationml/2006/main">
   <p:cSld>
     <p:spTree>
       <p:nvGrpSpPr>
@@ -4829,7 +4678,14 @@
         <p:cNvGrpSpPr/>
         <p:nvPr/>
       </p:nvGrpSpPr>
-      <p:grpSpPr/>
+      <p:grpSpPr>
+        <a:xfrm>
+          <a:off x="0" y="0"/>
+          <a:ext cx="0" cy="0"/>
+          <a:chOff x="0" y="0"/>
+          <a:chExt cx="0" cy="0"/>
+        </a:xfrm>
+      </p:grpSpPr>
       <p:pic>
         <p:nvPicPr>
           <p:cNvPr id="2" name="Picture 1" descr="p-17.png"/>
@@ -4839,7 +4695,7 @@
           <p:nvPr/>
         </p:nvPicPr>
         <p:blipFill>
-          <a:blip r:embed="rId2"/>
+          <a:blip r:embed="rId3"/>
           <a:stretch>
             <a:fillRect/>
           </a:stretch>
@@ -4863,7 +4719,7 @@
 </file>
 
 <file path=ppt/slides/slide2.xml><?xml version="1.0" encoding="utf-8"?>
-<p:sld xmlns:a="http://schemas.openxmlformats.org/drawingml/2006/main" xmlns:p="http://schemas.openxmlformats.org/presentationml/2006/main" xmlns:r="http://schemas.openxmlformats.org/officeDocument/2006/relationships">
+<p:sld xmlns:a="http://schemas.openxmlformats.org/drawingml/2006/main" xmlns:r="http://schemas.openxmlformats.org/officeDocument/2006/relationships" xmlns:p="http://schemas.openxmlformats.org/presentationml/2006/main">
   <p:cSld>
     <p:spTree>
       <p:nvGrpSpPr>
@@ -4871,7 +4727,14 @@
         <p:cNvGrpSpPr/>
         <p:nvPr/>
       </p:nvGrpSpPr>
-      <p:grpSpPr/>
+      <p:grpSpPr>
+        <a:xfrm>
+          <a:off x="0" y="0"/>
+          <a:ext cx="0" cy="0"/>
+          <a:chOff x="0" y="0"/>
+          <a:chExt cx="0" cy="0"/>
+        </a:xfrm>
+      </p:grpSpPr>
       <p:pic>
         <p:nvPicPr>
           <p:cNvPr id="2" name="Picture 1" descr="p-02.png"/>
@@ -4881,7 +4744,7 @@
           <p:nvPr/>
         </p:nvPicPr>
         <p:blipFill>
-          <a:blip r:embed="rId2"/>
+          <a:blip r:embed="rId3"/>
           <a:stretch>
             <a:fillRect/>
           </a:stretch>
@@ -4905,7 +4768,7 @@
 </file>
 
 <file path=ppt/slides/slide3.xml><?xml version="1.0" encoding="utf-8"?>
-<p:sld xmlns:a="http://schemas.openxmlformats.org/drawingml/2006/main" xmlns:p="http://schemas.openxmlformats.org/presentationml/2006/main" xmlns:r="http://schemas.openxmlformats.org/officeDocument/2006/relationships">
+<p:sld xmlns:a="http://schemas.openxmlformats.org/drawingml/2006/main" xmlns:r="http://schemas.openxmlformats.org/officeDocument/2006/relationships" xmlns:p="http://schemas.openxmlformats.org/presentationml/2006/main">
   <p:cSld>
     <p:spTree>
       <p:nvGrpSpPr>
@@ -4913,7 +4776,14 @@
         <p:cNvGrpSpPr/>
         <p:nvPr/>
       </p:nvGrpSpPr>
-      <p:grpSpPr/>
+      <p:grpSpPr>
+        <a:xfrm>
+          <a:off x="0" y="0"/>
+          <a:ext cx="0" cy="0"/>
+          <a:chOff x="0" y="0"/>
+          <a:chExt cx="0" cy="0"/>
+        </a:xfrm>
+      </p:grpSpPr>
       <p:pic>
         <p:nvPicPr>
           <p:cNvPr id="2" name="Picture 1" descr="p-03.png"/>
@@ -4947,7 +4817,7 @@
 </file>
 
 <file path=ppt/slides/slide4.xml><?xml version="1.0" encoding="utf-8"?>
-<p:sld xmlns:a="http://schemas.openxmlformats.org/drawingml/2006/main" xmlns:p="http://schemas.openxmlformats.org/presentationml/2006/main" xmlns:r="http://schemas.openxmlformats.org/officeDocument/2006/relationships">
+<p:sld xmlns:a="http://schemas.openxmlformats.org/drawingml/2006/main" xmlns:r="http://schemas.openxmlformats.org/officeDocument/2006/relationships" xmlns:p="http://schemas.openxmlformats.org/presentationml/2006/main">
   <p:cSld>
     <p:spTree>
       <p:nvGrpSpPr>
@@ -4955,7 +4825,14 @@
         <p:cNvGrpSpPr/>
         <p:nvPr/>
       </p:nvGrpSpPr>
-      <p:grpSpPr/>
+      <p:grpSpPr>
+        <a:xfrm>
+          <a:off x="0" y="0"/>
+          <a:ext cx="0" cy="0"/>
+          <a:chOff x="0" y="0"/>
+          <a:chExt cx="0" cy="0"/>
+        </a:xfrm>
+      </p:grpSpPr>
       <p:pic>
         <p:nvPicPr>
           <p:cNvPr id="2" name="Picture 1" descr="p-04.png"/>
@@ -4965,7 +4842,7 @@
           <p:nvPr/>
         </p:nvPicPr>
         <p:blipFill>
-          <a:blip r:embed="rId2"/>
+          <a:blip r:embed="rId3"/>
           <a:stretch>
             <a:fillRect/>
           </a:stretch>
@@ -4989,7 +4866,7 @@
 </file>
 
 <file path=ppt/slides/slide5.xml><?xml version="1.0" encoding="utf-8"?>
-<p:sld xmlns:a="http://schemas.openxmlformats.org/drawingml/2006/main" xmlns:p="http://schemas.openxmlformats.org/presentationml/2006/main" xmlns:r="http://schemas.openxmlformats.org/officeDocument/2006/relationships">
+<p:sld xmlns:a="http://schemas.openxmlformats.org/drawingml/2006/main" xmlns:r="http://schemas.openxmlformats.org/officeDocument/2006/relationships" xmlns:p="http://schemas.openxmlformats.org/presentationml/2006/main">
   <p:cSld>
     <p:spTree>
       <p:nvGrpSpPr>
@@ -4997,7 +4874,14 @@
         <p:cNvGrpSpPr/>
         <p:nvPr/>
       </p:nvGrpSpPr>
-      <p:grpSpPr/>
+      <p:grpSpPr>
+        <a:xfrm>
+          <a:off x="0" y="0"/>
+          <a:ext cx="0" cy="0"/>
+          <a:chOff x="0" y="0"/>
+          <a:chExt cx="0" cy="0"/>
+        </a:xfrm>
+      </p:grpSpPr>
       <p:pic>
         <p:nvPicPr>
           <p:cNvPr id="2" name="Picture 1" descr="p-05.png"/>
@@ -5007,7 +4891,7 @@
           <p:nvPr/>
         </p:nvPicPr>
         <p:blipFill>
-          <a:blip r:embed="rId2"/>
+          <a:blip r:embed="rId3"/>
           <a:stretch>
             <a:fillRect/>
           </a:stretch>
@@ -5031,7 +4915,7 @@
 </file>
 
 <file path=ppt/slides/slide6.xml><?xml version="1.0" encoding="utf-8"?>
-<p:sld xmlns:a="http://schemas.openxmlformats.org/drawingml/2006/main" xmlns:p="http://schemas.openxmlformats.org/presentationml/2006/main" xmlns:r="http://schemas.openxmlformats.org/officeDocument/2006/relationships">
+<p:sld xmlns:a="http://schemas.openxmlformats.org/drawingml/2006/main" xmlns:r="http://schemas.openxmlformats.org/officeDocument/2006/relationships" xmlns:p="http://schemas.openxmlformats.org/presentationml/2006/main">
   <p:cSld>
     <p:spTree>
       <p:nvGrpSpPr>
@@ -5039,7 +4923,14 @@
         <p:cNvGrpSpPr/>
         <p:nvPr/>
       </p:nvGrpSpPr>
-      <p:grpSpPr/>
+      <p:grpSpPr>
+        <a:xfrm>
+          <a:off x="0" y="0"/>
+          <a:ext cx="0" cy="0"/>
+          <a:chOff x="0" y="0"/>
+          <a:chExt cx="0" cy="0"/>
+        </a:xfrm>
+      </p:grpSpPr>
       <p:pic>
         <p:nvPicPr>
           <p:cNvPr id="2" name="Picture 1" descr="p-06.png"/>
@@ -5073,7 +4964,7 @@
 </file>
 
 <file path=ppt/slides/slide7.xml><?xml version="1.0" encoding="utf-8"?>
-<p:sld xmlns:a="http://schemas.openxmlformats.org/drawingml/2006/main" xmlns:p="http://schemas.openxmlformats.org/presentationml/2006/main" xmlns:r="http://schemas.openxmlformats.org/officeDocument/2006/relationships">
+<p:sld xmlns:a="http://schemas.openxmlformats.org/drawingml/2006/main" xmlns:r="http://schemas.openxmlformats.org/officeDocument/2006/relationships" xmlns:p="http://schemas.openxmlformats.org/presentationml/2006/main">
   <p:cSld>
     <p:spTree>
       <p:nvGrpSpPr>
@@ -5081,7 +4972,14 @@
         <p:cNvGrpSpPr/>
         <p:nvPr/>
       </p:nvGrpSpPr>
-      <p:grpSpPr/>
+      <p:grpSpPr>
+        <a:xfrm>
+          <a:off x="0" y="0"/>
+          <a:ext cx="0" cy="0"/>
+          <a:chOff x="0" y="0"/>
+          <a:chExt cx="0" cy="0"/>
+        </a:xfrm>
+      </p:grpSpPr>
       <p:pic>
         <p:nvPicPr>
           <p:cNvPr id="2" name="Picture 1" descr="p-07.png"/>
@@ -5091,7 +4989,7 @@
           <p:nvPr/>
         </p:nvPicPr>
         <p:blipFill>
-          <a:blip r:embed="rId2"/>
+          <a:blip r:embed="rId3"/>
           <a:stretch>
             <a:fillRect/>
           </a:stretch>
@@ -5115,7 +5013,7 @@
 </file>
 
 <file path=ppt/slides/slide8.xml><?xml version="1.0" encoding="utf-8"?>
-<p:sld xmlns:a="http://schemas.openxmlformats.org/drawingml/2006/main" xmlns:p="http://schemas.openxmlformats.org/presentationml/2006/main" xmlns:r="http://schemas.openxmlformats.org/officeDocument/2006/relationships">
+<p:sld xmlns:a="http://schemas.openxmlformats.org/drawingml/2006/main" xmlns:r="http://schemas.openxmlformats.org/officeDocument/2006/relationships" xmlns:p="http://schemas.openxmlformats.org/presentationml/2006/main">
   <p:cSld>
     <p:spTree>
       <p:nvGrpSpPr>
@@ -5123,7 +5021,14 @@
         <p:cNvGrpSpPr/>
         <p:nvPr/>
       </p:nvGrpSpPr>
-      <p:grpSpPr/>
+      <p:grpSpPr>
+        <a:xfrm>
+          <a:off x="0" y="0"/>
+          <a:ext cx="0" cy="0"/>
+          <a:chOff x="0" y="0"/>
+          <a:chExt cx="0" cy="0"/>
+        </a:xfrm>
+      </p:grpSpPr>
       <p:pic>
         <p:nvPicPr>
           <p:cNvPr id="2" name="Picture 1" descr="p-08.png"/>
@@ -5133,7 +5038,7 @@
           <p:nvPr/>
         </p:nvPicPr>
         <p:blipFill>
-          <a:blip r:embed="rId2"/>
+          <a:blip r:embed="rId3"/>
           <a:stretch>
             <a:fillRect/>
           </a:stretch>
@@ -5157,7 +5062,7 @@
 </file>
 
 <file path=ppt/slides/slide9.xml><?xml version="1.0" encoding="utf-8"?>
-<p:sld xmlns:a="http://schemas.openxmlformats.org/drawingml/2006/main" xmlns:p="http://schemas.openxmlformats.org/presentationml/2006/main" xmlns:r="http://schemas.openxmlformats.org/officeDocument/2006/relationships">
+<p:sld xmlns:a="http://schemas.openxmlformats.org/drawingml/2006/main" xmlns:r="http://schemas.openxmlformats.org/officeDocument/2006/relationships" xmlns:p="http://schemas.openxmlformats.org/presentationml/2006/main">
   <p:cSld>
     <p:spTree>
       <p:nvGrpSpPr>
@@ -5165,7 +5070,14 @@
         <p:cNvGrpSpPr/>
         <p:nvPr/>
       </p:nvGrpSpPr>
-      <p:grpSpPr/>
+      <p:grpSpPr>
+        <a:xfrm>
+          <a:off x="0" y="0"/>
+          <a:ext cx="0" cy="0"/>
+          <a:chOff x="0" y="0"/>
+          <a:chExt cx="0" cy="0"/>
+        </a:xfrm>
+      </p:grpSpPr>
       <p:pic>
         <p:nvPicPr>
           <p:cNvPr id="2" name="Picture 1" descr="p-09.png"/>
@@ -5529,44 +5441,44 @@
         <a:sysClr val="window" lastClr="FFFFFF"/>
       </a:lt1>
       <a:dk2>
-        <a:srgbClr val="1F497D"/>
+        <a:srgbClr val="44546A"/>
       </a:dk2>
       <a:lt2>
-        <a:srgbClr val="EEECE1"/>
+        <a:srgbClr val="E7E6E6"/>
       </a:lt2>
       <a:accent1>
-        <a:srgbClr val="4F81BD"/>
+        <a:srgbClr val="4472C4"/>
       </a:accent1>
       <a:accent2>
-        <a:srgbClr val="C0504D"/>
+        <a:srgbClr val="ED7D31"/>
       </a:accent2>
       <a:accent3>
-        <a:srgbClr val="9BBB59"/>
+        <a:srgbClr val="A5A5A5"/>
       </a:accent3>
       <a:accent4>
-        <a:srgbClr val="8064A2"/>
+        <a:srgbClr val="FFC000"/>
       </a:accent4>
       <a:accent5>
-        <a:srgbClr val="4BACC6"/>
+        <a:srgbClr val="5B9BD5"/>
       </a:accent5>
       <a:accent6>
-        <a:srgbClr val="F79646"/>
+        <a:srgbClr val="70AD47"/>
       </a:accent6>
       <a:hlink>
-        <a:srgbClr val="0000FF"/>
+        <a:srgbClr val="0563C1"/>
       </a:hlink>
       <a:folHlink>
-        <a:srgbClr val="800080"/>
+        <a:srgbClr val="954F72"/>
       </a:folHlink>
     </a:clrScheme>
     <a:fontScheme name="Office">
       <a:majorFont>
-        <a:latin typeface="Calibri"/>
+        <a:latin typeface="Calibri Light" panose="020F0302020204030204"/>
         <a:ea typeface=""/>
         <a:cs typeface=""/>
-        <a:font script="Jpan" typeface="ＭＳ Ｐゴシック"/>
+        <a:font script="Jpan" typeface="游ゴシック Light"/>
         <a:font script="Hang" typeface="맑은 고딕"/>
-        <a:font script="Hans" typeface="宋体"/>
+        <a:font script="Hans" typeface="等线 Light"/>
         <a:font script="Hant" typeface="新細明體"/>
         <a:font script="Arab" typeface="Times New Roman"/>
         <a:font script="Hebr" typeface="Times New Roman"/>
@@ -5594,14 +5506,31 @@
         <a:font script="Viet" typeface="Times New Roman"/>
         <a:font script="Uigh" typeface="Microsoft Uighur"/>
         <a:font script="Geor" typeface="Sylfaen"/>
+        <a:font script="Armn" typeface="Arial"/>
+        <a:font script="Bugi" typeface="Leelawadee UI"/>
+        <a:font script="Bopo" typeface="Microsoft JhengHei"/>
+        <a:font script="Java" typeface="Javanese Text"/>
+        <a:font script="Lisu" typeface="Segoe UI"/>
+        <a:font script="Mymr" typeface="Myanmar Text"/>
+        <a:font script="Nkoo" typeface="Ebrima"/>
+        <a:font script="Olck" typeface="Nirmala UI"/>
+        <a:font script="Osma" typeface="Ebrima"/>
+        <a:font script="Phag" typeface="Phagspa"/>
+        <a:font script="Syrn" typeface="Estrangelo Edessa"/>
+        <a:font script="Syrj" typeface="Estrangelo Edessa"/>
+        <a:font script="Syre" typeface="Estrangelo Edessa"/>
+        <a:font script="Sora" typeface="Nirmala UI"/>
+        <a:font script="Tale" typeface="Microsoft Tai Le"/>
+        <a:font script="Talu" typeface="Microsoft New Tai Lue"/>
+        <a:font script="Tfng" typeface="Ebrima"/>
       </a:majorFont>
       <a:minorFont>
-        <a:latin typeface="Calibri"/>
+        <a:latin typeface="Calibri" panose="020F0502020204030204"/>
         <a:ea typeface=""/>
         <a:cs typeface=""/>
-        <a:font script="Jpan" typeface="ＭＳ Ｐゴシック"/>
+        <a:font script="Jpan" typeface="游ゴシック"/>
         <a:font script="Hang" typeface="맑은 고딕"/>
-        <a:font script="Hans" typeface="宋体"/>
+        <a:font script="Hans" typeface="等线"/>
         <a:font script="Hant" typeface="新細明體"/>
         <a:font script="Arab" typeface="Arial"/>
         <a:font script="Hebr" typeface="Arial"/>
@@ -5629,6 +5558,23 @@
         <a:font script="Viet" typeface="Arial"/>
         <a:font script="Uigh" typeface="Microsoft Uighur"/>
         <a:font script="Geor" typeface="Sylfaen"/>
+        <a:font script="Armn" typeface="Arial"/>
+        <a:font script="Bugi" typeface="Leelawadee UI"/>
+        <a:font script="Bopo" typeface="Microsoft JhengHei"/>
+        <a:font script="Java" typeface="Javanese Text"/>
+        <a:font script="Lisu" typeface="Segoe UI"/>
+        <a:font script="Mymr" typeface="Myanmar Text"/>
+        <a:font script="Nkoo" typeface="Ebrima"/>
+        <a:font script="Olck" typeface="Nirmala UI"/>
+        <a:font script="Osma" typeface="Ebrima"/>
+        <a:font script="Phag" typeface="Phagspa"/>
+        <a:font script="Syrn" typeface="Estrangelo Edessa"/>
+        <a:font script="Syrj" typeface="Estrangelo Edessa"/>
+        <a:font script="Syre" typeface="Estrangelo Edessa"/>
+        <a:font script="Sora" typeface="Nirmala UI"/>
+        <a:font script="Tale" typeface="Microsoft Tai Le"/>
+        <a:font script="Talu" typeface="Microsoft New Tai Lue"/>
+        <a:font script="Tfng" typeface="Ebrima"/>
       </a:minorFont>
     </a:fontScheme>
     <a:fmtScheme name="Office">
@@ -5640,200 +5586,141 @@
           <a:gsLst>
             <a:gs pos="0">
               <a:schemeClr val="phClr">
-                <a:tint val="50000"/>
-                <a:satMod val="300000"/>
+                <a:lumMod val="110000"/>
+                <a:satMod val="105000"/>
+                <a:tint val="67000"/>
               </a:schemeClr>
             </a:gs>
-            <a:gs pos="35000">
+            <a:gs pos="50000">
               <a:schemeClr val="phClr">
-                <a:tint val="37000"/>
-                <a:satMod val="300000"/>
+                <a:lumMod val="105000"/>
+                <a:satMod val="103000"/>
+                <a:tint val="73000"/>
               </a:schemeClr>
             </a:gs>
             <a:gs pos="100000">
               <a:schemeClr val="phClr">
-                <a:tint val="15000"/>
-                <a:satMod val="350000"/>
+                <a:lumMod val="105000"/>
+                <a:satMod val="109000"/>
+                <a:tint val="81000"/>
               </a:schemeClr>
             </a:gs>
           </a:gsLst>
-          <a:lin ang="16200000" scaled="1"/>
+          <a:lin ang="5400000" scaled="0"/>
         </a:gradFill>
         <a:gradFill rotWithShape="1">
           <a:gsLst>
             <a:gs pos="0">
               <a:schemeClr val="phClr">
-                <a:tint val="100000"/>
+                <a:satMod val="103000"/>
+                <a:lumMod val="102000"/>
+                <a:tint val="94000"/>
+              </a:schemeClr>
+            </a:gs>
+            <a:gs pos="50000">
+              <a:schemeClr val="phClr">
+                <a:satMod val="110000"/>
+                <a:lumMod val="100000"/>
                 <a:shade val="100000"/>
-                <a:satMod val="130000"/>
               </a:schemeClr>
             </a:gs>
             <a:gs pos="100000">
               <a:schemeClr val="phClr">
-                <a:tint val="50000"/>
-                <a:shade val="100000"/>
-                <a:satMod val="350000"/>
+                <a:lumMod val="99000"/>
+                <a:satMod val="120000"/>
+                <a:shade val="78000"/>
               </a:schemeClr>
             </a:gs>
           </a:gsLst>
-          <a:lin ang="16200000" scaled="0"/>
+          <a:lin ang="5400000" scaled="0"/>
         </a:gradFill>
       </a:fillStyleLst>
       <a:lnStyleLst>
-        <a:ln w="9525" cap="flat" cmpd="sng" algn="ctr">
-          <a:solidFill>
-            <a:schemeClr val="phClr">
-              <a:shade val="95000"/>
-              <a:satMod val="105000"/>
-            </a:schemeClr>
-          </a:solidFill>
-          <a:prstDash val="solid"/>
-        </a:ln>
-        <a:ln w="25400" cap="flat" cmpd="sng" algn="ctr">
+        <a:ln w="6350" cap="flat" cmpd="sng" algn="ctr">
           <a:solidFill>
             <a:schemeClr val="phClr"/>
           </a:solidFill>
           <a:prstDash val="solid"/>
+          <a:miter lim="800000"/>
         </a:ln>
-        <a:ln w="38100" cap="flat" cmpd="sng" algn="ctr">
+        <a:ln w="12700" cap="flat" cmpd="sng" algn="ctr">
           <a:solidFill>
             <a:schemeClr val="phClr"/>
           </a:solidFill>
           <a:prstDash val="solid"/>
+          <a:miter lim="800000"/>
+        </a:ln>
+        <a:ln w="19050" cap="flat" cmpd="sng" algn="ctr">
+          <a:solidFill>
+            <a:schemeClr val="phClr"/>
+          </a:solidFill>
+          <a:prstDash val="solid"/>
+          <a:miter lim="800000"/>
         </a:ln>
       </a:lnStyleLst>
       <a:effectStyleLst>
         <a:effectStyle>
+          <a:effectLst/>
+        </a:effectStyle>
+        <a:effectStyle>
+          <a:effectLst/>
+        </a:effectStyle>
+        <a:effectStyle>
           <a:effectLst>
-            <a:outerShdw blurRad="40000" dist="20000" dir="5400000" rotWithShape="0">
+            <a:outerShdw blurRad="57150" dist="19050" dir="5400000" algn="ctr" rotWithShape="0">
               <a:srgbClr val="000000">
-                <a:alpha val="38000"/>
+                <a:alpha val="63000"/>
               </a:srgbClr>
             </a:outerShdw>
           </a:effectLst>
-        </a:effectStyle>
-        <a:effectStyle>
-          <a:effectLst>
-            <a:outerShdw blurRad="40000" dist="23000" dir="5400000" rotWithShape="0">
-              <a:srgbClr val="000000">
-                <a:alpha val="35000"/>
-              </a:srgbClr>
-            </a:outerShdw>
-          </a:effectLst>
-        </a:effectStyle>
-        <a:effectStyle>
-          <a:effectLst>
-            <a:outerShdw blurRad="40000" dist="23000" dir="5400000" rotWithShape="0">
-              <a:srgbClr val="000000">
-                <a:alpha val="35000"/>
-              </a:srgbClr>
-            </a:outerShdw>
-          </a:effectLst>
-          <a:scene3d>
-            <a:camera prst="orthographicFront">
-              <a:rot lat="0" lon="0" rev="0"/>
-            </a:camera>
-            <a:lightRig rig="threePt" dir="t">
-              <a:rot lat="0" lon="0" rev="1200000"/>
-            </a:lightRig>
-          </a:scene3d>
-          <a:sp3d>
-            <a:bevelT w="63500" h="25400"/>
-          </a:sp3d>
         </a:effectStyle>
       </a:effectStyleLst>
       <a:bgFillStyleLst>
         <a:solidFill>
           <a:schemeClr val="phClr"/>
         </a:solidFill>
+        <a:solidFill>
+          <a:schemeClr val="phClr">
+            <a:tint val="95000"/>
+            <a:satMod val="170000"/>
+          </a:schemeClr>
+        </a:solidFill>
         <a:gradFill rotWithShape="1">
           <a:gsLst>
             <a:gs pos="0">
               <a:schemeClr val="phClr">
-                <a:tint val="40000"/>
-                <a:satMod val="350000"/>
+                <a:tint val="93000"/>
+                <a:satMod val="150000"/>
+                <a:shade val="98000"/>
+                <a:lumMod val="102000"/>
               </a:schemeClr>
             </a:gs>
-            <a:gs pos="40000">
+            <a:gs pos="50000">
               <a:schemeClr val="phClr">
-                <a:tint val="45000"/>
-                <a:shade val="99000"/>
-                <a:satMod val="350000"/>
+                <a:tint val="98000"/>
+                <a:satMod val="130000"/>
+                <a:shade val="90000"/>
+                <a:lumMod val="103000"/>
               </a:schemeClr>
             </a:gs>
             <a:gs pos="100000">
               <a:schemeClr val="phClr">
-                <a:shade val="20000"/>
-                <a:satMod val="255000"/>
+                <a:shade val="63000"/>
+                <a:satMod val="120000"/>
               </a:schemeClr>
             </a:gs>
           </a:gsLst>
-          <a:path path="circle">
-            <a:fillToRect l="50000" t="-80000" r="50000" b="180000"/>
-          </a:path>
-        </a:gradFill>
-        <a:gradFill rotWithShape="1">
-          <a:gsLst>
-            <a:gs pos="0">
-              <a:schemeClr val="phClr">
-                <a:tint val="80000"/>
-                <a:satMod val="300000"/>
-              </a:schemeClr>
-            </a:gs>
-            <a:gs pos="100000">
-              <a:schemeClr val="phClr">
-                <a:shade val="30000"/>
-                <a:satMod val="200000"/>
-              </a:schemeClr>
-            </a:gs>
-          </a:gsLst>
-          <a:path path="circle">
-            <a:fillToRect l="50000" t="50000" r="50000" b="50000"/>
-          </a:path>
+          <a:lin ang="5400000" scaled="0"/>
         </a:gradFill>
       </a:bgFillStyleLst>
     </a:fmtScheme>
   </a:themeElements>
-  <a:objectDefaults>
-    <a:spDef>
-      <a:spPr/>
-      <a:bodyPr/>
-      <a:lstStyle/>
-      <a:style>
-        <a:lnRef idx="1">
-          <a:schemeClr val="accent1"/>
-        </a:lnRef>
-        <a:fillRef idx="3">
-          <a:schemeClr val="accent1"/>
-        </a:fillRef>
-        <a:effectRef idx="2">
-          <a:schemeClr val="accent1"/>
-        </a:effectRef>
-        <a:fontRef idx="minor">
-          <a:schemeClr val="lt1"/>
-        </a:fontRef>
-      </a:style>
-    </a:spDef>
-    <a:lnDef>
-      <a:spPr/>
-      <a:bodyPr/>
-      <a:lstStyle/>
-      <a:style>
-        <a:lnRef idx="2">
-          <a:schemeClr val="accent1"/>
-        </a:lnRef>
-        <a:fillRef idx="0">
-          <a:schemeClr val="accent1"/>
-        </a:fillRef>
-        <a:effectRef idx="1">
-          <a:schemeClr val="accent1"/>
-        </a:effectRef>
-        <a:fontRef idx="minor">
-          <a:schemeClr val="tx1"/>
-        </a:fontRef>
-      </a:style>
-    </a:lnDef>
-  </a:objectDefaults>
+  <a:objectDefaults/>
   <a:extraClrSchemeLst/>
+  <a:extLst>
+    <a:ext uri="{05A4C25C-085E-4340-85A3-A5531E510DB2}">
+      <thm15:themeFamily xmlns:thm15="http://schemas.microsoft.com/office/thememl/2012/main" name="Office Theme" id="{62F939B6-93AF-4DB8-9C6B-D6C7DFDC589F}" vid="{4A3C46E8-61CC-4603-A589-7422A47A8E4A}"/>
+    </a:ext>
+  </a:extLst>
 </a:theme>
 </file>
</xml_diff>